<commit_message>
fix: remove em dashes from copy, fix app name, wire Claude API for detection
Copy fixes:
- Replace all em dashes in user-facing strings with commas, colons, or periods
- Fix 'AI or Not' -> 'The Little Circle' in MobileInstallBanner

Claude API detection:
- Install @anthropic-ai/sdk
- detectWithClaude() handles text (claude-haiku-4-5) and images (claude-sonnet-4-5)
- Falls back to mock when ANTHROPIC_API_KEY is not set
- No more GPTZero dependency; add ANTHROPIC_API_KEY in Vercel env to go live

Co-Authored-By: Claude Sonnet 4.6 <noreply@anthropic.com>
</commit_message>
<xml_diff>
--- a/Docs/The-Little-Circle-Pitch-Deck.pptx
+++ b/Docs/The-Little-Circle-Pitch-Deck.pptx
@@ -4,6 +4,9 @@
   <p:sldMasterIdLst>
     <p:sldMasterId id="2147483648" r:id="rId1"/>
   </p:sldMasterIdLst>
+  <p:notesMasterIdLst>
+    <p:notesMasterId r:id="rId13"/>
+  </p:notesMasterIdLst>
   <p:sldIdLst>
     <p:sldId id="256" r:id="rId2"/>
     <p:sldId id="257" r:id="rId3"/>
@@ -17,9 +20,6 @@
     <p:sldId id="265" r:id="rId11"/>
     <p:sldId id="266" r:id="rId12"/>
   </p:sldIdLst>
-  <p:notesMasterIdLst>
-    <p:notesMasterId r:id="rId13"/>
-  </p:notesMasterIdLst>
   <p:sldSz cx="12192000" cy="6858000"/>
   <p:notesSz cx="6858000" cy="12192000"/>
   <p:defaultTextStyle>
@@ -114,6 +114,11 @@
       </a:defRPr>
     </a:lvl9pPr>
   </p:defaultTextStyle>
+  <p:extLst>
+    <p:ext uri="{EFAFB233-063F-42B5-8137-9DF3F51BA10A}">
+      <p15:sldGuideLst xmlns:p15="http://schemas.microsoft.com/office/powerpoint/2012/main"/>
+    </p:ext>
+  </p:extLst>
 </p:presentation>
 </file>
 
@@ -139,234 +144,10 @@
           <a:chExt cx="0" cy="0"/>
         </a:xfrm>
       </p:grpSpPr>
-      <p:sp>
-        <p:nvSpPr>
-          <p:cNvPr id="2" name="Header Placeholder 1"/>
-          <p:cNvSpPr>
-            <a:spLocks noGrp="1"/>
-          </p:cNvSpPr>
-          <p:nvPr>
-            <p:ph type="hdr" sz="quarter"/>
-          </p:nvPr>
-        </p:nvSpPr>
-        <p:spPr>
-          <a:xfrm>
-            <a:off x="0" y="0"/>
-            <a:ext cx="2971800" cy="458788"/>
-          </a:xfrm>
-          <a:prstGeom prst="rect">
-            <a:avLst/>
-          </a:prstGeom>
-        </p:spPr>
-        <p:txBody>
-          <a:bodyPr vert="horz" lIns="91440" tIns="45720" rIns="91440" bIns="45720" rtlCol="0"/>
-          <a:lstStyle>
-            <a:lvl1pPr algn="l">
-              <a:defRPr sz="1200"/>
-            </a:lvl1pPr>
-          </a:lstStyle>
-          <a:p>
-            <a:endParaRPr lang="en-US"/>
-          </a:p>
-        </p:txBody>
-      </p:sp>
-      <p:sp>
-        <p:nvSpPr>
-          <p:cNvPr id="3" name="Date Placeholder 2"/>
-          <p:cNvSpPr>
-            <a:spLocks noGrp="1"/>
-          </p:cNvSpPr>
-          <p:nvPr>
-            <p:ph type="dt" idx="1"/>
-          </p:nvPr>
-        </p:nvSpPr>
-        <p:spPr>
-          <a:xfrm>
-            <a:off x="3884613" y="0"/>
-            <a:ext cx="2971800" cy="458788"/>
-          </a:xfrm>
-          <a:prstGeom prst="rect">
-            <a:avLst/>
-          </a:prstGeom>
-        </p:spPr>
-        <p:txBody>
-          <a:bodyPr vert="horz" lIns="91440" tIns="45720" rIns="91440" bIns="45720" rtlCol="0"/>
-          <a:lstStyle>
-            <a:lvl1pPr algn="r">
-              <a:defRPr sz="1200"/>
-            </a:lvl1pPr>
-          </a:lstStyle>
-          <a:p>
-            <a:fld id="{5282F153-3F37-0F45-9E97-73ACFA13230C}" type="datetimeFigureOut">
-              <a:rPr lang="en-US"/>
-              <a:t>7/23/19</a:t>
-            </a:fld>
-            <a:endParaRPr lang="en-US"/>
-          </a:p>
-        </p:txBody>
-      </p:sp>
-      <p:sp>
-        <p:nvSpPr>
-          <p:cNvPr id="4" name="Slide Image Placeholder 3"/>
-          <p:cNvSpPr>
-            <a:spLocks noGrp="1" noRot="1" noChangeAspect="1"/>
-          </p:cNvSpPr>
-          <p:nvPr>
-            <p:ph type="sldImg" idx="2"/>
-          </p:nvPr>
-        </p:nvSpPr>
-        <p:spPr>
-          <a:xfrm>
-            <a:off x="685800" y="1143000"/>
-            <a:ext cx="5486400" cy="3086100"/>
-          </a:xfrm>
-          <a:prstGeom prst="rect">
-            <a:avLst/>
-          </a:prstGeom>
-          <a:noFill/>
-          <a:ln w="12700">
-            <a:solidFill>
-              <a:prstClr val="black"/>
-            </a:solidFill>
-          </a:ln>
-        </p:spPr>
-        <p:txBody>
-          <a:bodyPr vert="horz" lIns="91440" tIns="45720" rIns="91440" bIns="45720" rtlCol="0" anchor="ctr"/>
-          <a:lstStyle/>
-          <a:p>
-            <a:endParaRPr lang="en-US"/>
-          </a:p>
-        </p:txBody>
-      </p:sp>
-      <p:sp>
-        <p:nvSpPr>
-          <p:cNvPr id="5" name="Notes Placeholder 4"/>
-          <p:cNvSpPr>
-            <a:spLocks noGrp="1"/>
-          </p:cNvSpPr>
-          <p:nvPr>
-            <p:ph type="body" sz="quarter" idx="3"/>
-          </p:nvPr>
-        </p:nvSpPr>
-        <p:spPr>
-          <a:xfrm>
-            <a:off x="685800" y="4400550"/>
-            <a:ext cx="5486400" cy="3600450"/>
-          </a:xfrm>
-          <a:prstGeom prst="rect">
-            <a:avLst/>
-          </a:prstGeom>
-        </p:spPr>
-        <p:txBody>
-          <a:bodyPr vert="horz" lIns="91440" tIns="45720" rIns="91440" bIns="45720" rtlCol="0"/>
-          <a:lstStyle/>
-          <a:p>
-            <a:pPr lvl="0"/>
-            <a:r>
-              <a:rPr lang="en-US"/>
-              <a:t>Click to edit Master text styles</a:t>
-            </a:r>
-          </a:p>
-          <a:p>
-            <a:pPr lvl="1"/>
-            <a:r>
-              <a:rPr lang="en-US"/>
-              <a:t>Second level</a:t>
-            </a:r>
-          </a:p>
-          <a:p>
-            <a:pPr lvl="2"/>
-            <a:r>
-              <a:rPr lang="en-US"/>
-              <a:t>Third level</a:t>
-            </a:r>
-          </a:p>
-          <a:p>
-            <a:pPr lvl="3"/>
-            <a:r>
-              <a:rPr lang="en-US"/>
-              <a:t>Fourth level</a:t>
-            </a:r>
-          </a:p>
-          <a:p>
-            <a:pPr lvl="4"/>
-            <a:r>
-              <a:rPr lang="en-US"/>
-              <a:t>Fifth level</a:t>
-            </a:r>
-          </a:p>
-        </p:txBody>
-      </p:sp>
-      <p:sp>
-        <p:nvSpPr>
-          <p:cNvPr id="6" name="Footer Placeholder 5"/>
-          <p:cNvSpPr>
-            <a:spLocks noGrp="1"/>
-          </p:cNvSpPr>
-          <p:nvPr>
-            <p:ph type="ftr" sz="quarter" idx="4"/>
-          </p:nvPr>
-        </p:nvSpPr>
-        <p:spPr>
-          <a:xfrm>
-            <a:off x="0" y="8685213"/>
-            <a:ext cx="2971800" cy="458787"/>
-          </a:xfrm>
-          <a:prstGeom prst="rect">
-            <a:avLst/>
-          </a:prstGeom>
-        </p:spPr>
-        <p:txBody>
-          <a:bodyPr vert="horz" lIns="91440" tIns="45720" rIns="91440" bIns="45720" rtlCol="0" anchor="b"/>
-          <a:lstStyle>
-            <a:lvl1pPr algn="l">
-              <a:defRPr sz="1200"/>
-            </a:lvl1pPr>
-          </a:lstStyle>
-          <a:p>
-            <a:endParaRPr lang="en-US"/>
-          </a:p>
-        </p:txBody>
-      </p:sp>
-      <p:sp>
-        <p:nvSpPr>
-          <p:cNvPr id="7" name="Slide Number Placeholder 6"/>
-          <p:cNvSpPr>
-            <a:spLocks noGrp="1"/>
-          </p:cNvSpPr>
-          <p:nvPr>
-            <p:ph type="sldNum" sz="quarter" idx="5"/>
-          </p:nvPr>
-        </p:nvSpPr>
-        <p:spPr>
-          <a:xfrm>
-            <a:off x="3884613" y="8685213"/>
-            <a:ext cx="2971800" cy="458787"/>
-          </a:xfrm>
-          <a:prstGeom prst="rect">
-            <a:avLst/>
-          </a:prstGeom>
-        </p:spPr>
-        <p:txBody>
-          <a:bodyPr vert="horz" lIns="91440" tIns="45720" rIns="91440" bIns="45720" rtlCol="0" anchor="b"/>
-          <a:lstStyle>
-            <a:lvl1pPr algn="r">
-              <a:defRPr sz="1200"/>
-            </a:lvl1pPr>
-          </a:lstStyle>
-          <a:p>
-            <a:fld id="{CE5E9CC1-C706-0F49-92D6-E571CC5EEA8F}" type="slidenum">
-              <a:rPr lang="en-US"/>
-              <a:t>‹#›</a:t>
-            </a:fld>
-            <a:endParaRPr lang="en-US"/>
-          </a:p>
-        </p:txBody>
-      </p:sp>
     </p:spTree>
     <p:extLst>
       <p:ext uri="{BB962C8B-B14F-4D97-AF65-F5344CB8AC3E}">
-        <p14:creationId xmlns:p14="http://schemas.microsoft.com/office/powerpoint/2010/main" val="1024086991"/>
+        <p14:creationId xmlns:p14="http://schemas.microsoft.com/office/powerpoint/2010/main" val="2863448326"/>
       </p:ext>
     </p:extLst>
   </p:cSld>
@@ -510,10 +291,6 @@
           <a:bodyPr/>
           <a:lstStyle/>
           <a:p>
-            <a:r>
-              <a:rPr lang="en-US" dirty="0"/>
-              <a:t/>
-            </a:r>
             <a:endParaRPr lang="en-US" dirty="0"/>
           </a:p>
         </p:txBody>
@@ -598,10 +375,6 @@
           <a:bodyPr/>
           <a:lstStyle/>
           <a:p>
-            <a:r>
-              <a:rPr lang="en-US" dirty="0"/>
-              <a:t/>
-            </a:r>
             <a:endParaRPr lang="en-US" dirty="0"/>
           </a:p>
         </p:txBody>
@@ -686,10 +459,6 @@
           <a:bodyPr/>
           <a:lstStyle/>
           <a:p>
-            <a:r>
-              <a:rPr lang="en-US" dirty="0"/>
-              <a:t/>
-            </a:r>
             <a:endParaRPr lang="en-US" dirty="0"/>
           </a:p>
         </p:txBody>
@@ -774,10 +543,6 @@
           <a:bodyPr/>
           <a:lstStyle/>
           <a:p>
-            <a:r>
-              <a:rPr lang="en-US" dirty="0"/>
-              <a:t/>
-            </a:r>
             <a:endParaRPr lang="en-US" dirty="0"/>
           </a:p>
         </p:txBody>
@@ -862,10 +627,6 @@
           <a:bodyPr/>
           <a:lstStyle/>
           <a:p>
-            <a:r>
-              <a:rPr lang="en-US" dirty="0"/>
-              <a:t/>
-            </a:r>
             <a:endParaRPr lang="en-US" dirty="0"/>
           </a:p>
         </p:txBody>
@@ -950,10 +711,6 @@
           <a:bodyPr/>
           <a:lstStyle/>
           <a:p>
-            <a:r>
-              <a:rPr lang="en-US" dirty="0"/>
-              <a:t/>
-            </a:r>
             <a:endParaRPr lang="en-US" dirty="0"/>
           </a:p>
         </p:txBody>
@@ -1038,10 +795,6 @@
           <a:bodyPr/>
           <a:lstStyle/>
           <a:p>
-            <a:r>
-              <a:rPr lang="en-US" dirty="0"/>
-              <a:t/>
-            </a:r>
             <a:endParaRPr lang="en-US" dirty="0"/>
           </a:p>
         </p:txBody>
@@ -1126,10 +879,6 @@
           <a:bodyPr/>
           <a:lstStyle/>
           <a:p>
-            <a:r>
-              <a:rPr lang="en-US" dirty="0"/>
-              <a:t/>
-            </a:r>
             <a:endParaRPr lang="en-US" dirty="0"/>
           </a:p>
         </p:txBody>
@@ -1214,10 +963,6 @@
           <a:bodyPr/>
           <a:lstStyle/>
           <a:p>
-            <a:r>
-              <a:rPr lang="en-US" dirty="0"/>
-              <a:t/>
-            </a:r>
             <a:endParaRPr lang="en-US" dirty="0"/>
           </a:p>
         </p:txBody>
@@ -1302,10 +1047,6 @@
           <a:bodyPr/>
           <a:lstStyle/>
           <a:p>
-            <a:r>
-              <a:rPr lang="en-US" dirty="0"/>
-              <a:t/>
-            </a:r>
             <a:endParaRPr lang="en-US" dirty="0"/>
           </a:p>
         </p:txBody>
@@ -1390,10 +1131,6 @@
           <a:bodyPr/>
           <a:lstStyle/>
           <a:p>
-            <a:r>
-              <a:rPr lang="en-US" dirty="0"/>
-              <a:t/>
-            </a:r>
             <a:endParaRPr lang="en-US" dirty="0"/>
           </a:p>
         </p:txBody>
@@ -1467,6 +1204,11 @@
 <file path=ppt/slideMasters/slideMaster1.xml><?xml version="1.0" encoding="utf-8"?>
 <p:sldMaster xmlns:a="http://schemas.openxmlformats.org/drawingml/2006/main" xmlns:r="http://schemas.openxmlformats.org/officeDocument/2006/relationships" xmlns:p="http://schemas.openxmlformats.org/presentationml/2006/main">
   <p:cSld>
+    <p:bg>
+      <p:bgRef idx="1001">
+        <a:schemeClr val="bg1"/>
+      </p:bgRef>
+    </p:bg>
     <p:spTree>
       <p:nvGrpSpPr>
         <p:cNvPr id="1" name=""/>
@@ -1749,6 +1491,7 @@
         <a:solidFill>
           <a:srgbClr val="1A1A1A"/>
         </a:solidFill>
+        <a:effectLst/>
       </p:bgPr>
     </p:bg>
     <p:spTree>
@@ -1846,7 +1589,7 @@
           <a:bodyPr wrap="square" rtlCol="0" anchor="ctr"/>
           <a:lstStyle/>
           <a:p>
-            <a:pPr algn="ctr" indent="0" marL="0">
+            <a:pPr marL="0" indent="0" algn="ctr">
               <a:buNone/>
             </a:pPr>
             <a:r>
@@ -1885,7 +1628,7 @@
           <a:bodyPr wrap="square" rtlCol="0" anchor="ctr"/>
           <a:lstStyle/>
           <a:p>
-            <a:pPr algn="ctr" indent="0" marL="0">
+            <a:pPr marL="0" indent="0" algn="ctr">
               <a:buNone/>
             </a:pPr>
             <a:r>
@@ -1924,7 +1667,7 @@
           <a:bodyPr wrap="square" rtlCol="0" anchor="ctr"/>
           <a:lstStyle/>
           <a:p>
-            <a:pPr algn="ctr" indent="0" marL="0">
+            <a:pPr marL="0" indent="0" algn="ctr">
               <a:buNone/>
             </a:pPr>
             <a:r>
@@ -1958,6 +1701,7 @@
         <a:solidFill>
           <a:srgbClr val="1A1A1A"/>
         </a:solidFill>
+        <a:effectLst/>
       </p:bgPr>
     </p:bg>
     <p:spTree>
@@ -1995,7 +1739,7 @@
           <a:bodyPr wrap="square" rtlCol="0" anchor="ctr"/>
           <a:lstStyle/>
           <a:p>
-            <a:pPr indent="0" marL="0">
+            <a:pPr marL="0" indent="0">
               <a:buNone/>
             </a:pPr>
             <a:r>
@@ -2034,7 +1778,7 @@
           <a:bodyPr wrap="square" rtlCol="0" anchor="ctr"/>
           <a:lstStyle/>
           <a:p>
-            <a:pPr algn="ctr" indent="0" marL="0">
+            <a:pPr marL="0" indent="0" algn="ctr">
               <a:buNone/>
             </a:pPr>
             <a:r>
@@ -2073,7 +1817,7 @@
           <a:bodyPr wrap="square" rtlCol="0" anchor="ctr"/>
           <a:lstStyle/>
           <a:p>
-            <a:pPr algn="ctr" indent="0" marL="0">
+            <a:pPr marL="0" indent="0" algn="ctr">
               <a:buNone/>
             </a:pPr>
             <a:r>
@@ -2134,7 +1878,7 @@
           <a:bodyPr wrap="square" rtlCol="0" anchor="ctr"/>
           <a:lstStyle/>
           <a:p>
-            <a:pPr algn="ctr" indent="0" marL="0">
+            <a:pPr marL="0" indent="0" algn="ctr">
               <a:buNone/>
             </a:pPr>
             <a:r>
@@ -2173,7 +1917,7 @@
           <a:bodyPr wrap="square" rtlCol="0" anchor="ctr"/>
           <a:lstStyle/>
           <a:p>
-            <a:pPr algn="ctr" indent="0" marL="0">
+            <a:pPr marL="0" indent="0" algn="ctr">
               <a:buNone/>
             </a:pPr>
             <a:r>
@@ -2212,7 +1956,7 @@
           <a:bodyPr wrap="square" rtlCol="0" anchor="ctr"/>
           <a:lstStyle/>
           <a:p>
-            <a:pPr algn="ctr" indent="0" marL="0">
+            <a:pPr marL="0" indent="0" algn="ctr">
               <a:buNone/>
             </a:pPr>
             <a:r>
@@ -2273,7 +2017,7 @@
           <a:bodyPr wrap="square" rtlCol="0" anchor="ctr"/>
           <a:lstStyle/>
           <a:p>
-            <a:pPr algn="ctr" indent="0" marL="0">
+            <a:pPr marL="0" indent="0" algn="ctr">
               <a:buNone/>
             </a:pPr>
             <a:r>
@@ -2312,7 +2056,7 @@
           <a:bodyPr wrap="square" rtlCol="0" anchor="ctr"/>
           <a:lstStyle/>
           <a:p>
-            <a:pPr algn="ctr" indent="0" marL="0">
+            <a:pPr marL="0" indent="0" algn="ctr">
               <a:buNone/>
             </a:pPr>
             <a:r>
@@ -2351,7 +2095,7 @@
           <a:bodyPr wrap="square" rtlCol="0" anchor="ctr"/>
           <a:lstStyle/>
           <a:p>
-            <a:pPr algn="ctr" indent="0" marL="0">
+            <a:pPr marL="0" indent="0" algn="ctr">
               <a:buNone/>
             </a:pPr>
             <a:r>
@@ -2412,7 +2156,7 @@
           <a:bodyPr wrap="square" rtlCol="0" anchor="ctr"/>
           <a:lstStyle/>
           <a:p>
-            <a:pPr algn="ctr" indent="0" marL="0">
+            <a:pPr marL="0" indent="0" algn="ctr">
               <a:buNone/>
             </a:pPr>
             <a:r>
@@ -2451,7 +2195,7 @@
           <a:bodyPr wrap="square" rtlCol="0" anchor="ctr"/>
           <a:lstStyle/>
           <a:p>
-            <a:pPr algn="ctr" indent="0" marL="0">
+            <a:pPr marL="0" indent="0" algn="ctr">
               <a:buNone/>
             </a:pPr>
             <a:r>
@@ -2490,7 +2234,7 @@
           <a:bodyPr wrap="square" rtlCol="0" anchor="ctr"/>
           <a:lstStyle/>
           <a:p>
-            <a:pPr algn="ctr" indent="0" marL="0">
+            <a:pPr marL="0" indent="0" algn="ctr">
               <a:buNone/>
             </a:pPr>
             <a:r>
@@ -2551,7 +2295,7 @@
           <a:bodyPr wrap="square" rtlCol="0" anchor="ctr"/>
           <a:lstStyle/>
           <a:p>
-            <a:pPr algn="ctr" indent="0" marL="0">
+            <a:pPr marL="0" indent="0" algn="ctr">
               <a:buNone/>
             </a:pPr>
             <a:r>
@@ -2590,7 +2334,7 @@
           <a:bodyPr wrap="square" rtlCol="0" anchor="ctr"/>
           <a:lstStyle/>
           <a:p>
-            <a:pPr algn="ctr" indent="0" marL="0">
+            <a:pPr marL="0" indent="0" algn="ctr">
               <a:buNone/>
             </a:pPr>
             <a:r>
@@ -2629,7 +2373,7 @@
           <a:bodyPr wrap="square" rtlCol="0" anchor="ctr"/>
           <a:lstStyle/>
           <a:p>
-            <a:pPr algn="ctr" indent="0" marL="0">
+            <a:pPr marL="0" indent="0" algn="ctr">
               <a:buNone/>
             </a:pPr>
             <a:r>
@@ -2668,7 +2412,7 @@
           <a:bodyPr wrap="square" rtlCol="0" anchor="ctr"/>
           <a:lstStyle/>
           <a:p>
-            <a:pPr algn="ctr" indent="0" marL="0">
+            <a:pPr marL="0" indent="0" algn="ctr">
               <a:buNone/>
             </a:pPr>
             <a:r>
@@ -2702,6 +2446,7 @@
         <a:solidFill>
           <a:srgbClr val="1A1A1A"/>
         </a:solidFill>
+        <a:effectLst/>
       </p:bgPr>
     </p:bg>
     <p:spTree>
@@ -2799,7 +2544,7 @@
           <a:bodyPr wrap="square" rtlCol="0" anchor="ctr"/>
           <a:lstStyle/>
           <a:p>
-            <a:pPr algn="ctr" indent="0" marL="0">
+            <a:pPr marL="0" indent="0" algn="ctr">
               <a:buNone/>
             </a:pPr>
             <a:r>
@@ -2816,7 +2561,7 @@
             <a:endParaRPr lang="en-US" sz="3600" dirty="0"/>
           </a:p>
           <a:p>
-            <a:pPr algn="ctr" indent="0" marL="0">
+            <a:pPr marL="0" indent="0" algn="ctr">
               <a:buNone/>
             </a:pPr>
             <a:r>
@@ -2855,7 +2600,7 @@
           <a:bodyPr wrap="square" rtlCol="0" anchor="ctr"/>
           <a:lstStyle/>
           <a:p>
-            <a:pPr algn="ctr" indent="0" marL="0">
+            <a:pPr marL="0" indent="0" algn="ctr">
               <a:buNone/>
             </a:pPr>
             <a:r>
@@ -2894,7 +2639,7 @@
           <a:bodyPr wrap="square" rtlCol="0" anchor="ctr"/>
           <a:lstStyle/>
           <a:p>
-            <a:pPr algn="ctr" indent="0" marL="0">
+            <a:pPr marL="0" indent="0" algn="ctr">
               <a:buNone/>
             </a:pPr>
             <a:r>
@@ -2933,7 +2678,7 @@
           <a:bodyPr wrap="square" rtlCol="0" anchor="ctr"/>
           <a:lstStyle/>
           <a:p>
-            <a:pPr algn="ctr" indent="0" marL="0">
+            <a:pPr marL="0" indent="0" algn="ctr">
               <a:buNone/>
             </a:pPr>
             <a:r>
@@ -2967,6 +2712,7 @@
         <a:solidFill>
           <a:srgbClr val="1A1A1A"/>
         </a:solidFill>
+        <a:effectLst/>
       </p:bgPr>
     </p:bg>
     <p:spTree>
@@ -3004,7 +2750,7 @@
           <a:bodyPr wrap="square" rtlCol="0" anchor="ctr"/>
           <a:lstStyle/>
           <a:p>
-            <a:pPr indent="0" marL="0">
+            <a:pPr marL="0" indent="0">
               <a:buNone/>
             </a:pPr>
             <a:r>
@@ -3043,7 +2789,7 @@
           <a:bodyPr wrap="square" rtlCol="0" anchor="ctr"/>
           <a:lstStyle/>
           <a:p>
-            <a:pPr indent="0" marL="0">
+            <a:pPr marL="0" indent="0">
               <a:buNone/>
             </a:pPr>
             <a:r>
@@ -3104,7 +2850,7 @@
           <a:bodyPr wrap="square" rtlCol="0" anchor="ctr"/>
           <a:lstStyle/>
           <a:p>
-            <a:pPr algn="ctr" indent="0" marL="0">
+            <a:pPr marL="0" indent="0" algn="ctr">
               <a:buNone/>
             </a:pPr>
             <a:r>
@@ -3143,7 +2889,7 @@
           <a:bodyPr wrap="square" rtlCol="0" anchor="ctr"/>
           <a:lstStyle/>
           <a:p>
-            <a:pPr algn="ctr" indent="0" marL="0">
+            <a:pPr marL="0" indent="0" algn="ctr">
               <a:buNone/>
             </a:pPr>
             <a:r>
@@ -3160,7 +2906,7 @@
             <a:endParaRPr lang="en-US" sz="1400" dirty="0"/>
           </a:p>
           <a:p>
-            <a:pPr algn="ctr" indent="0" marL="0">
+            <a:pPr marL="0" indent="0" algn="ctr">
               <a:buNone/>
             </a:pPr>
             <a:r>
@@ -3221,7 +2967,7 @@
           <a:bodyPr wrap="square" rtlCol="0" anchor="ctr"/>
           <a:lstStyle/>
           <a:p>
-            <a:pPr algn="ctr" indent="0" marL="0">
+            <a:pPr marL="0" indent="0" algn="ctr">
               <a:buNone/>
             </a:pPr>
             <a:r>
@@ -3260,7 +3006,7 @@
           <a:bodyPr wrap="square" rtlCol="0" anchor="ctr"/>
           <a:lstStyle/>
           <a:p>
-            <a:pPr algn="ctr" indent="0" marL="0">
+            <a:pPr marL="0" indent="0" algn="ctr">
               <a:buNone/>
             </a:pPr>
             <a:r>
@@ -3277,7 +3023,7 @@
             <a:endParaRPr lang="en-US" sz="1400" dirty="0"/>
           </a:p>
           <a:p>
-            <a:pPr algn="ctr" indent="0" marL="0">
+            <a:pPr marL="0" indent="0" algn="ctr">
               <a:buNone/>
             </a:pPr>
             <a:r>
@@ -3338,7 +3084,7 @@
           <a:bodyPr wrap="square" rtlCol="0" anchor="ctr"/>
           <a:lstStyle/>
           <a:p>
-            <a:pPr algn="ctr" indent="0" marL="0">
+            <a:pPr marL="0" indent="0" algn="ctr">
               <a:buNone/>
             </a:pPr>
             <a:r>
@@ -3377,7 +3123,7 @@
           <a:bodyPr wrap="square" rtlCol="0" anchor="ctr"/>
           <a:lstStyle/>
           <a:p>
-            <a:pPr algn="ctr" indent="0" marL="0">
+            <a:pPr marL="0" indent="0" algn="ctr">
               <a:buNone/>
             </a:pPr>
             <a:r>
@@ -3394,7 +3140,7 @@
             <a:endParaRPr lang="en-US" sz="1400" dirty="0"/>
           </a:p>
           <a:p>
-            <a:pPr algn="ctr" indent="0" marL="0">
+            <a:pPr marL="0" indent="0" algn="ctr">
               <a:buNone/>
             </a:pPr>
             <a:r>
@@ -3433,7 +3179,7 @@
           <a:bodyPr wrap="square" rtlCol="0" anchor="ctr"/>
           <a:lstStyle/>
           <a:p>
-            <a:pPr indent="0" marL="0">
+            <a:pPr marL="0" indent="0">
               <a:buNone/>
             </a:pPr>
             <a:r>
@@ -3445,7 +3191,29 @@
                 <a:ea typeface="Arial" pitchFamily="34" charset="-122"/>
                 <a:cs typeface="Arial" pitchFamily="34" charset="-120"/>
               </a:rPr>
-              <a:t>AI-generated images, videos, voices, and text are everywhere — social media, news, dating apps, business communications. People are getting fooled daily, and it's only getting worse.</a:t>
+              <a:t>AI-generated images, videos, voices, and text are </a:t>
+            </a:r>
+            <a:r>
+              <a:rPr lang="en-US" sz="1600" dirty="0" smtClean="0">
+                <a:solidFill>
+                  <a:srgbClr val="888888"/>
+                </a:solidFill>
+                <a:latin typeface="Arial" pitchFamily="34" charset="0"/>
+                <a:ea typeface="Arial" pitchFamily="34" charset="-122"/>
+                <a:cs typeface="Arial" pitchFamily="34" charset="-120"/>
+              </a:rPr>
+              <a:t>everywhere, </a:t>
+            </a:r>
+            <a:r>
+              <a:rPr lang="en-US" sz="1600" dirty="0">
+                <a:solidFill>
+                  <a:srgbClr val="888888"/>
+                </a:solidFill>
+                <a:latin typeface="Arial" pitchFamily="34" charset="0"/>
+                <a:ea typeface="Arial" pitchFamily="34" charset="-122"/>
+                <a:cs typeface="Arial" pitchFamily="34" charset="-120"/>
+              </a:rPr>
+              <a:t>social media, news, dating apps, business communications. People are getting fooled daily, and it's only getting worse.</a:t>
             </a:r>
             <a:endParaRPr lang="en-US" sz="1600" dirty="0"/>
           </a:p>
@@ -3467,6 +3235,7 @@
         <a:solidFill>
           <a:srgbClr val="FFFFFF"/>
         </a:solidFill>
+        <a:effectLst/>
       </p:bgPr>
     </p:bg>
     <p:spTree>
@@ -3504,7 +3273,7 @@
           <a:bodyPr wrap="square" rtlCol="0" anchor="ctr"/>
           <a:lstStyle/>
           <a:p>
-            <a:pPr indent="0" marL="0">
+            <a:pPr marL="0" indent="0">
               <a:buNone/>
             </a:pPr>
             <a:r>
@@ -3543,7 +3312,7 @@
           <a:bodyPr wrap="square" rtlCol="0" anchor="ctr"/>
           <a:lstStyle/>
           <a:p>
-            <a:pPr indent="0" marL="0">
+            <a:pPr marL="0" indent="0">
               <a:buNone/>
             </a:pPr>
             <a:r>
@@ -3582,7 +3351,7 @@
           <a:bodyPr wrap="square" rtlCol="0" anchor="ctr"/>
           <a:lstStyle/>
           <a:p>
-            <a:pPr indent="0" marL="0">
+            <a:pPr marL="0" indent="0">
               <a:buNone/>
             </a:pPr>
             <a:r>
@@ -3594,7 +3363,29 @@
                 <a:ea typeface="Arial" pitchFamily="34" charset="-122"/>
                 <a:cs typeface="Arial" pitchFamily="34" charset="-120"/>
               </a:rPr>
-              <a:t>The Little Circle is an AI detection companion — a small floating circle that lives on your screen. Tap it, and it tells you instantly if what you're seeing is AI-generated.</a:t>
+              <a:t>The Little Circle is an AI detection </a:t>
+            </a:r>
+            <a:r>
+              <a:rPr lang="en-US" sz="1800" dirty="0" smtClean="0">
+                <a:solidFill>
+                  <a:srgbClr val="1A1A1A"/>
+                </a:solidFill>
+                <a:latin typeface="Arial" pitchFamily="34" charset="0"/>
+                <a:ea typeface="Arial" pitchFamily="34" charset="-122"/>
+                <a:cs typeface="Arial" pitchFamily="34" charset="-120"/>
+              </a:rPr>
+              <a:t>companion </a:t>
+            </a:r>
+            <a:r>
+              <a:rPr lang="en-US" sz="1800" dirty="0">
+                <a:solidFill>
+                  <a:srgbClr val="1A1A1A"/>
+                </a:solidFill>
+                <a:latin typeface="Arial" pitchFamily="34" charset="0"/>
+                <a:ea typeface="Arial" pitchFamily="34" charset="-122"/>
+                <a:cs typeface="Arial" pitchFamily="34" charset="-120"/>
+              </a:rPr>
+              <a:t>a small floating circle that lives on your screen. Tap it, and it tells you instantly if what you're seeing is AI-generated.</a:t>
             </a:r>
             <a:endParaRPr lang="en-US" sz="1800" dirty="0"/>
           </a:p>
@@ -3641,7 +3432,7 @@
           <a:bodyPr wrap="square" rtlCol="0" anchor="ctr"/>
           <a:lstStyle/>
           <a:p>
-            <a:pPr indent="0" marL="0">
+            <a:pPr marL="0" indent="0">
               <a:buNone/>
             </a:pPr>
             <a:r>
@@ -3653,7 +3444,29 @@
                 <a:ea typeface="Arial" pitchFamily="34" charset="-122"/>
                 <a:cs typeface="Arial" pitchFamily="34" charset="-120"/>
               </a:rPr>
-              <a:t>Works on any content — images, video, text, audio</a:t>
+              <a:t>Works on any </a:t>
+            </a:r>
+            <a:r>
+              <a:rPr lang="en-US" sz="1600" dirty="0" smtClean="0">
+                <a:solidFill>
+                  <a:srgbClr val="1A1A1A"/>
+                </a:solidFill>
+                <a:latin typeface="Arial" pitchFamily="34" charset="0"/>
+                <a:ea typeface="Arial" pitchFamily="34" charset="-122"/>
+                <a:cs typeface="Arial" pitchFamily="34" charset="-120"/>
+              </a:rPr>
+              <a:t>content: </a:t>
+            </a:r>
+            <a:r>
+              <a:rPr lang="en-US" sz="1600" dirty="0">
+                <a:solidFill>
+                  <a:srgbClr val="1A1A1A"/>
+                </a:solidFill>
+                <a:latin typeface="Arial" pitchFamily="34" charset="0"/>
+                <a:ea typeface="Arial" pitchFamily="34" charset="-122"/>
+                <a:cs typeface="Arial" pitchFamily="34" charset="-120"/>
+              </a:rPr>
+              <a:t>images, video, text, audio</a:t>
             </a:r>
             <a:endParaRPr lang="en-US" sz="1600" dirty="0"/>
           </a:p>
@@ -3700,7 +3513,7 @@
           <a:bodyPr wrap="square" rtlCol="0" anchor="ctr"/>
           <a:lstStyle/>
           <a:p>
-            <a:pPr indent="0" marL="0">
+            <a:pPr marL="0" indent="0">
               <a:buNone/>
             </a:pPr>
             <a:r>
@@ -3759,7 +3572,7 @@
           <a:bodyPr wrap="square" rtlCol="0" anchor="ctr"/>
           <a:lstStyle/>
           <a:p>
-            <a:pPr indent="0" marL="0">
+            <a:pPr marL="0" indent="0">
               <a:buNone/>
             </a:pPr>
             <a:r>
@@ -3818,7 +3631,7 @@
           </a:solidFill>
           <a:ln/>
           <a:effectLst>
-            <a:outerShdw sx="100000" sy="100000" kx="0" ky="0" algn="bl" rotWithShape="0" blurRad="101600" dist="25400" dir="2700000">
+            <a:outerShdw blurRad="101600" dist="25400" dir="2700000" algn="bl" rotWithShape="0">
               <a:srgbClr val="000000">
                 <a:alpha val="20000"/>
               </a:srgbClr>
@@ -3887,7 +3700,7 @@
           <a:bodyPr wrap="square" rtlCol="0" anchor="ctr"/>
           <a:lstStyle/>
           <a:p>
-            <a:pPr algn="ctr" indent="0" marL="0">
+            <a:pPr marL="0" indent="0" algn="ctr">
               <a:buNone/>
             </a:pPr>
             <a:r>
@@ -3904,7 +3717,7 @@
             <a:endParaRPr lang="en-US" sz="2800" dirty="0"/>
           </a:p>
           <a:p>
-            <a:pPr algn="ctr" indent="0" marL="0">
+            <a:pPr marL="0" indent="0" algn="ctr">
               <a:buNone/>
             </a:pPr>
             <a:r>
@@ -3938,6 +3751,7 @@
         <a:solidFill>
           <a:srgbClr val="FFFFFF"/>
         </a:solidFill>
+        <a:effectLst/>
       </p:bgPr>
     </p:bg>
     <p:spTree>
@@ -3975,7 +3789,7 @@
           <a:bodyPr wrap="square" rtlCol="0" anchor="ctr"/>
           <a:lstStyle/>
           <a:p>
-            <a:pPr indent="0" marL="0">
+            <a:pPr marL="0" indent="0">
               <a:buNone/>
             </a:pPr>
             <a:r>
@@ -4014,7 +3828,7 @@
           <a:bodyPr wrap="square" rtlCol="0" anchor="ctr"/>
           <a:lstStyle/>
           <a:p>
-            <a:pPr indent="0" marL="0">
+            <a:pPr marL="0" indent="0">
               <a:buNone/>
             </a:pPr>
             <a:r>
@@ -4073,7 +3887,7 @@
           <a:bodyPr wrap="square" rtlCol="0" anchor="ctr"/>
           <a:lstStyle/>
           <a:p>
-            <a:pPr algn="ctr" indent="0" marL="0">
+            <a:pPr marL="0" indent="0" algn="ctr">
               <a:buNone/>
             </a:pPr>
             <a:r>
@@ -4112,7 +3926,7 @@
           <a:bodyPr wrap="square" rtlCol="0" anchor="ctr"/>
           <a:lstStyle/>
           <a:p>
-            <a:pPr algn="ctr" indent="0" marL="0">
+            <a:pPr marL="0" indent="0" algn="ctr">
               <a:buNone/>
             </a:pPr>
             <a:r>
@@ -4151,7 +3965,7 @@
           <a:bodyPr wrap="square" rtlCol="0" anchor="ctr"/>
           <a:lstStyle/>
           <a:p>
-            <a:pPr algn="ctr" indent="0" marL="0">
+            <a:pPr marL="0" indent="0" algn="ctr">
               <a:buNone/>
             </a:pPr>
             <a:r>
@@ -4210,7 +4024,7 @@
           <a:bodyPr wrap="square" rtlCol="0" anchor="ctr"/>
           <a:lstStyle/>
           <a:p>
-            <a:pPr algn="ctr" indent="0" marL="0">
+            <a:pPr marL="0" indent="0" algn="ctr">
               <a:buNone/>
             </a:pPr>
             <a:r>
@@ -4249,7 +4063,7 @@
           <a:bodyPr wrap="square" rtlCol="0" anchor="ctr"/>
           <a:lstStyle/>
           <a:p>
-            <a:pPr algn="ctr" indent="0" marL="0">
+            <a:pPr marL="0" indent="0" algn="ctr">
               <a:buNone/>
             </a:pPr>
             <a:r>
@@ -4288,7 +4102,7 @@
           <a:bodyPr wrap="square" rtlCol="0" anchor="ctr"/>
           <a:lstStyle/>
           <a:p>
-            <a:pPr algn="ctr" indent="0" marL="0">
+            <a:pPr marL="0" indent="0" algn="ctr">
               <a:buNone/>
             </a:pPr>
             <a:r>
@@ -4347,7 +4161,7 @@
           <a:bodyPr wrap="square" rtlCol="0" anchor="ctr"/>
           <a:lstStyle/>
           <a:p>
-            <a:pPr algn="ctr" indent="0" marL="0">
+            <a:pPr marL="0" indent="0" algn="ctr">
               <a:buNone/>
             </a:pPr>
             <a:r>
@@ -4386,7 +4200,7 @@
           <a:bodyPr wrap="square" rtlCol="0" anchor="ctr"/>
           <a:lstStyle/>
           <a:p>
-            <a:pPr algn="ctr" indent="0" marL="0">
+            <a:pPr marL="0" indent="0" algn="ctr">
               <a:buNone/>
             </a:pPr>
             <a:r>
@@ -4425,7 +4239,7 @@
           <a:bodyPr wrap="square" rtlCol="0" anchor="ctr"/>
           <a:lstStyle/>
           <a:p>
-            <a:pPr algn="ctr" indent="0" marL="0">
+            <a:pPr marL="0" indent="0" algn="ctr">
               <a:buNone/>
             </a:pPr>
             <a:r>
@@ -4464,7 +4278,7 @@
           <a:bodyPr wrap="square" rtlCol="0" anchor="ctr"/>
           <a:lstStyle/>
           <a:p>
-            <a:pPr algn="ctr" indent="0" marL="0">
+            <a:pPr marL="0" indent="0" algn="ctr">
               <a:buNone/>
             </a:pPr>
             <a:r>
@@ -4503,7 +4317,7 @@
           <a:bodyPr wrap="square" rtlCol="0" anchor="ctr"/>
           <a:lstStyle/>
           <a:p>
-            <a:pPr algn="ctr" indent="0" marL="0">
+            <a:pPr marL="0" indent="0" algn="ctr">
               <a:buNone/>
             </a:pPr>
             <a:r>
@@ -4562,7 +4376,7 @@
           <a:bodyPr wrap="square" rtlCol="0" anchor="ctr"/>
           <a:lstStyle/>
           <a:p>
-            <a:pPr algn="ctr" indent="0" marL="0">
+            <a:pPr marL="0" indent="0" algn="ctr">
               <a:buNone/>
             </a:pPr>
             <a:r>
@@ -4598,7 +4412,7 @@
           <a:bodyPr wrap="square" rtlCol="0" anchor="ctr"/>
           <a:lstStyle/>
           <a:p>
-            <a:pPr algn="ctr" indent="0" marL="0">
+            <a:pPr marL="0" indent="0" algn="ctr">
               <a:buNone/>
             </a:pPr>
             <a:r>
@@ -4637,7 +4451,7 @@
           <a:bodyPr wrap="square" rtlCol="0" anchor="ctr"/>
           <a:lstStyle/>
           <a:p>
-            <a:pPr algn="ctr" indent="0" marL="0">
+            <a:pPr marL="0" indent="0" algn="ctr">
               <a:buNone/>
             </a:pPr>
             <a:r>
@@ -4673,7 +4487,7 @@
           <a:bodyPr wrap="square" rtlCol="0" anchor="ctr"/>
           <a:lstStyle/>
           <a:p>
-            <a:pPr algn="ctr" indent="0" marL="0">
+            <a:pPr marL="0" indent="0" algn="ctr">
               <a:buNone/>
             </a:pPr>
             <a:r>
@@ -4712,7 +4526,7 @@
           <a:bodyPr wrap="square" rtlCol="0" anchor="ctr"/>
           <a:lstStyle/>
           <a:p>
-            <a:pPr algn="ctr" indent="0" marL="0">
+            <a:pPr marL="0" indent="0" algn="ctr">
               <a:buNone/>
             </a:pPr>
             <a:r>
@@ -4748,7 +4562,7 @@
           <a:bodyPr wrap="square" rtlCol="0" anchor="ctr"/>
           <a:lstStyle/>
           <a:p>
-            <a:pPr algn="ctr" indent="0" marL="0">
+            <a:pPr marL="0" indent="0" algn="ctr">
               <a:buNone/>
             </a:pPr>
             <a:r>
@@ -4787,7 +4601,7 @@
           <a:bodyPr wrap="square" rtlCol="0" anchor="ctr"/>
           <a:lstStyle/>
           <a:p>
-            <a:pPr algn="ctr" indent="0" marL="0">
+            <a:pPr marL="0" indent="0" algn="ctr">
               <a:buNone/>
             </a:pPr>
             <a:r>
@@ -4823,7 +4637,7 @@
           <a:bodyPr wrap="square" rtlCol="0" anchor="ctr"/>
           <a:lstStyle/>
           <a:p>
-            <a:pPr algn="ctr" indent="0" marL="0">
+            <a:pPr marL="0" indent="0" algn="ctr">
               <a:buNone/>
             </a:pPr>
             <a:r>
@@ -4857,6 +4671,7 @@
         <a:solidFill>
           <a:srgbClr val="1A1A1A"/>
         </a:solidFill>
+        <a:effectLst/>
       </p:bgPr>
     </p:bg>
     <p:spTree>
@@ -4894,7 +4709,7 @@
           <a:bodyPr wrap="square" rtlCol="0" anchor="ctr"/>
           <a:lstStyle/>
           <a:p>
-            <a:pPr indent="0" marL="0">
+            <a:pPr marL="0" indent="0">
               <a:buNone/>
             </a:pPr>
             <a:r>
@@ -4933,7 +4748,7 @@
           <a:bodyPr wrap="square" rtlCol="0" anchor="ctr"/>
           <a:lstStyle/>
           <a:p>
-            <a:pPr indent="0" marL="0">
+            <a:pPr marL="0" indent="0">
               <a:buNone/>
             </a:pPr>
             <a:r>
@@ -4994,7 +4809,7 @@
           <a:bodyPr wrap="square" rtlCol="0" anchor="ctr"/>
           <a:lstStyle/>
           <a:p>
-            <a:pPr algn="ctr" indent="0" marL="0">
+            <a:pPr marL="0" indent="0" algn="ctr">
               <a:buNone/>
             </a:pPr>
             <a:r>
@@ -5033,7 +4848,7 @@
           <a:bodyPr wrap="square" rtlCol="0" anchor="ctr"/>
           <a:lstStyle/>
           <a:p>
-            <a:pPr algn="ctr" indent="0" marL="0">
+            <a:pPr marL="0" indent="0" algn="ctr">
               <a:buNone/>
             </a:pPr>
             <a:r>
@@ -5072,7 +4887,7 @@
           <a:bodyPr wrap="square" rtlCol="0" anchor="ctr"/>
           <a:lstStyle/>
           <a:p>
-            <a:pPr algn="ctr" indent="0" marL="0">
+            <a:pPr marL="0" indent="0" algn="ctr">
               <a:buNone/>
             </a:pPr>
             <a:r>
@@ -5089,7 +4904,7 @@
             <a:endParaRPr lang="en-US" sz="1300" dirty="0"/>
           </a:p>
           <a:p>
-            <a:pPr algn="ctr" indent="0" marL="0">
+            <a:pPr marL="0" indent="0" algn="ctr">
               <a:buNone/>
             </a:pPr>
             <a:r>
@@ -5150,7 +4965,7 @@
           <a:bodyPr wrap="square" rtlCol="0" anchor="ctr"/>
           <a:lstStyle/>
           <a:p>
-            <a:pPr algn="ctr" indent="0" marL="0">
+            <a:pPr marL="0" indent="0" algn="ctr">
               <a:buNone/>
             </a:pPr>
             <a:r>
@@ -5189,7 +5004,7 @@
           <a:bodyPr wrap="square" rtlCol="0" anchor="ctr"/>
           <a:lstStyle/>
           <a:p>
-            <a:pPr algn="ctr" indent="0" marL="0">
+            <a:pPr marL="0" indent="0" algn="ctr">
               <a:buNone/>
             </a:pPr>
             <a:r>
@@ -5228,7 +5043,7 @@
           <a:bodyPr wrap="square" rtlCol="0" anchor="ctr"/>
           <a:lstStyle/>
           <a:p>
-            <a:pPr algn="ctr" indent="0" marL="0">
+            <a:pPr marL="0" indent="0" algn="ctr">
               <a:buNone/>
             </a:pPr>
             <a:r>
@@ -5245,7 +5060,7 @@
             <a:endParaRPr lang="en-US" sz="1300" dirty="0"/>
           </a:p>
           <a:p>
-            <a:pPr algn="ctr" indent="0" marL="0">
+            <a:pPr marL="0" indent="0" algn="ctr">
               <a:buNone/>
             </a:pPr>
             <a:r>
@@ -5306,7 +5121,7 @@
           <a:bodyPr wrap="square" rtlCol="0" anchor="ctr"/>
           <a:lstStyle/>
           <a:p>
-            <a:pPr algn="ctr" indent="0" marL="0">
+            <a:pPr marL="0" indent="0" algn="ctr">
               <a:buNone/>
             </a:pPr>
             <a:r>
@@ -5345,7 +5160,7 @@
           <a:bodyPr wrap="square" rtlCol="0" anchor="ctr"/>
           <a:lstStyle/>
           <a:p>
-            <a:pPr algn="ctr" indent="0" marL="0">
+            <a:pPr marL="0" indent="0" algn="ctr">
               <a:buNone/>
             </a:pPr>
             <a:r>
@@ -5384,7 +5199,7 @@
           <a:bodyPr wrap="square" rtlCol="0" anchor="ctr"/>
           <a:lstStyle/>
           <a:p>
-            <a:pPr algn="ctr" indent="0" marL="0">
+            <a:pPr marL="0" indent="0" algn="ctr">
               <a:buNone/>
             </a:pPr>
             <a:r>
@@ -5401,7 +5216,7 @@
             <a:endParaRPr lang="en-US" sz="1300" dirty="0"/>
           </a:p>
           <a:p>
-            <a:pPr algn="ctr" indent="0" marL="0">
+            <a:pPr marL="0" indent="0" algn="ctr">
               <a:buNone/>
             </a:pPr>
             <a:r>
@@ -5440,7 +5255,7 @@
           <a:bodyPr wrap="square" rtlCol="0" anchor="ctr"/>
           <a:lstStyle/>
           <a:p>
-            <a:pPr indent="0" marL="0">
+            <a:pPr marL="0" indent="0">
               <a:buNone/>
             </a:pPr>
             <a:r>
@@ -5474,6 +5289,7 @@
         <a:solidFill>
           <a:srgbClr val="FFFFFF"/>
         </a:solidFill>
+        <a:effectLst/>
       </p:bgPr>
     </p:bg>
     <p:spTree>
@@ -5511,7 +5327,7 @@
           <a:bodyPr wrap="square" rtlCol="0" anchor="ctr"/>
           <a:lstStyle/>
           <a:p>
-            <a:pPr indent="0" marL="0">
+            <a:pPr marL="0" indent="0">
               <a:buNone/>
             </a:pPr>
             <a:r>
@@ -5550,7 +5366,7 @@
           <a:bodyPr wrap="square" rtlCol="0" anchor="ctr"/>
           <a:lstStyle/>
           <a:p>
-            <a:pPr indent="0" marL="0">
+            <a:pPr marL="0" indent="0">
               <a:buNone/>
             </a:pPr>
             <a:r>
@@ -5611,7 +5427,7 @@
           <a:bodyPr wrap="square" rtlCol="0" anchor="ctr"/>
           <a:lstStyle/>
           <a:p>
-            <a:pPr algn="ctr" indent="0" marL="0">
+            <a:pPr marL="0" indent="0" algn="ctr">
               <a:buNone/>
             </a:pPr>
             <a:r>
@@ -5650,7 +5466,7 @@
           <a:bodyPr wrap="square" rtlCol="0" anchor="ctr"/>
           <a:lstStyle/>
           <a:p>
-            <a:pPr algn="ctr" indent="0" marL="0">
+            <a:pPr marL="0" indent="0" algn="ctr">
               <a:buNone/>
             </a:pPr>
             <a:r>
@@ -5689,7 +5505,7 @@
           <a:bodyPr wrap="square" rtlCol="0" anchor="ctr"/>
           <a:lstStyle/>
           <a:p>
-            <a:pPr indent="0" marL="0">
+            <a:pPr marL="0" indent="0">
               <a:buNone/>
             </a:pPr>
             <a:r>
@@ -5728,7 +5544,7 @@
           <a:bodyPr wrap="square" rtlCol="0" anchor="ctr"/>
           <a:lstStyle/>
           <a:p>
-            <a:pPr indent="0" marL="0">
+            <a:pPr marL="0" indent="0">
               <a:buNone/>
             </a:pPr>
             <a:r>
@@ -5767,7 +5583,7 @@
           <a:bodyPr wrap="square" rtlCol="0" anchor="ctr"/>
           <a:lstStyle/>
           <a:p>
-            <a:pPr indent="0" marL="0">
+            <a:pPr marL="0" indent="0">
               <a:buNone/>
             </a:pPr>
             <a:r>
@@ -5828,7 +5644,7 @@
           <a:bodyPr wrap="square" rtlCol="0" anchor="ctr"/>
           <a:lstStyle/>
           <a:p>
-            <a:pPr algn="ctr" indent="0" marL="0">
+            <a:pPr marL="0" indent="0" algn="ctr">
               <a:buNone/>
             </a:pPr>
             <a:r>
@@ -5867,7 +5683,7 @@
           <a:bodyPr wrap="square" rtlCol="0" anchor="ctr"/>
           <a:lstStyle/>
           <a:p>
-            <a:pPr algn="ctr" indent="0" marL="0">
+            <a:pPr marL="0" indent="0" algn="ctr">
               <a:buNone/>
             </a:pPr>
             <a:r>
@@ -5906,7 +5722,7 @@
           <a:bodyPr wrap="square" rtlCol="0" anchor="ctr"/>
           <a:lstStyle/>
           <a:p>
-            <a:pPr indent="0" marL="0">
+            <a:pPr marL="0" indent="0">
               <a:buNone/>
             </a:pPr>
             <a:r>
@@ -5945,7 +5761,7 @@
           <a:bodyPr wrap="square" rtlCol="0" anchor="ctr"/>
           <a:lstStyle/>
           <a:p>
-            <a:pPr indent="0" marL="0">
+            <a:pPr marL="0" indent="0">
               <a:buNone/>
             </a:pPr>
             <a:r>
@@ -5984,7 +5800,7 @@
           <a:bodyPr wrap="square" rtlCol="0" anchor="ctr"/>
           <a:lstStyle/>
           <a:p>
-            <a:pPr indent="0" marL="0">
+            <a:pPr marL="0" indent="0">
               <a:buNone/>
             </a:pPr>
             <a:r>
@@ -6023,7 +5839,7 @@
           <a:bodyPr wrap="square" rtlCol="0" anchor="ctr"/>
           <a:lstStyle/>
           <a:p>
-            <a:pPr indent="0" marL="0">
+            <a:pPr marL="0" indent="0">
               <a:buNone/>
             </a:pPr>
             <a:r>
@@ -6084,7 +5900,7 @@
           <a:bodyPr wrap="square" rtlCol="0" anchor="ctr"/>
           <a:lstStyle/>
           <a:p>
-            <a:pPr algn="ctr" indent="0" marL="0">
+            <a:pPr marL="0" indent="0" algn="ctr">
               <a:buNone/>
             </a:pPr>
             <a:r>
@@ -6123,7 +5939,7 @@
           <a:bodyPr wrap="square" rtlCol="0" anchor="ctr"/>
           <a:lstStyle/>
           <a:p>
-            <a:pPr algn="ctr" indent="0" marL="0">
+            <a:pPr marL="0" indent="0" algn="ctr">
               <a:buNone/>
             </a:pPr>
             <a:r>
@@ -6162,7 +5978,7 @@
           <a:bodyPr wrap="square" rtlCol="0" anchor="ctr"/>
           <a:lstStyle/>
           <a:p>
-            <a:pPr indent="0" marL="0">
+            <a:pPr marL="0" indent="0">
               <a:buNone/>
             </a:pPr>
             <a:r>
@@ -6201,7 +6017,7 @@
           <a:bodyPr wrap="square" rtlCol="0" anchor="ctr"/>
           <a:lstStyle/>
           <a:p>
-            <a:pPr indent="0" marL="0">
+            <a:pPr marL="0" indent="0">
               <a:buNone/>
             </a:pPr>
             <a:r>
@@ -6240,7 +6056,7 @@
           <a:bodyPr wrap="square" rtlCol="0" anchor="ctr"/>
           <a:lstStyle/>
           <a:p>
-            <a:pPr indent="0" marL="0">
+            <a:pPr marL="0" indent="0">
               <a:buNone/>
             </a:pPr>
             <a:r>
@@ -6279,7 +6095,7 @@
           <a:bodyPr wrap="square" rtlCol="0" anchor="ctr"/>
           <a:lstStyle/>
           <a:p>
-            <a:pPr indent="0" marL="0">
+            <a:pPr marL="0" indent="0">
               <a:buNone/>
             </a:pPr>
             <a:r>
@@ -6318,7 +6134,7 @@
           <a:bodyPr wrap="square" rtlCol="0" anchor="ctr"/>
           <a:lstStyle/>
           <a:p>
-            <a:pPr algn="ctr" indent="0" marL="0">
+            <a:pPr marL="0" indent="0" algn="ctr">
               <a:buNone/>
             </a:pPr>
             <a:r>
@@ -6352,6 +6168,7 @@
         <a:solidFill>
           <a:srgbClr val="FFFFFF"/>
         </a:solidFill>
+        <a:effectLst/>
       </p:bgPr>
     </p:bg>
     <p:spTree>
@@ -6389,7 +6206,7 @@
           <a:bodyPr wrap="square" rtlCol="0" anchor="ctr"/>
           <a:lstStyle/>
           <a:p>
-            <a:pPr indent="0" marL="0">
+            <a:pPr marL="0" indent="0">
               <a:buNone/>
             </a:pPr>
             <a:r>
@@ -6428,7 +6245,7 @@
           <a:bodyPr wrap="square" rtlCol="0" anchor="ctr"/>
           <a:lstStyle/>
           <a:p>
-            <a:pPr indent="0" marL="0">
+            <a:pPr marL="0" indent="0">
               <a:buNone/>
             </a:pPr>
             <a:r>
@@ -6467,7 +6284,7 @@
           <a:bodyPr wrap="square" rtlCol="0" anchor="ctr"/>
           <a:lstStyle/>
           <a:p>
-            <a:pPr algn="ctr" indent="0" marL="0">
+            <a:pPr marL="0" indent="0" algn="ctr">
               <a:buNone/>
             </a:pPr>
             <a:endParaRPr lang="en-US" sz="1400" dirty="0"/>
@@ -6495,7 +6312,7 @@
           <a:bodyPr wrap="square" rtlCol="0" anchor="ctr"/>
           <a:lstStyle/>
           <a:p>
-            <a:pPr algn="ctr" indent="0" marL="0">
+            <a:pPr marL="0" indent="0" algn="ctr">
               <a:buNone/>
             </a:pPr>
             <a:r>
@@ -6534,7 +6351,7 @@
           <a:bodyPr wrap="square" rtlCol="0" anchor="ctr"/>
           <a:lstStyle/>
           <a:p>
-            <a:pPr algn="ctr" indent="0" marL="0">
+            <a:pPr marL="0" indent="0" algn="ctr">
               <a:buNone/>
             </a:pPr>
             <a:r>
@@ -6573,7 +6390,7 @@
           <a:bodyPr wrap="square" rtlCol="0" anchor="ctr"/>
           <a:lstStyle/>
           <a:p>
-            <a:pPr algn="ctr" indent="0" marL="0">
+            <a:pPr marL="0" indent="0" algn="ctr">
               <a:buNone/>
             </a:pPr>
             <a:r>
@@ -6612,7 +6429,7 @@
           <a:bodyPr wrap="square" rtlCol="0" anchor="ctr"/>
           <a:lstStyle/>
           <a:p>
-            <a:pPr algn="l" indent="0" marL="0">
+            <a:pPr marL="0" indent="0" algn="l">
               <a:buNone/>
             </a:pPr>
             <a:r>
@@ -6651,7 +6468,7 @@
           <a:bodyPr wrap="square" rtlCol="0" anchor="ctr"/>
           <a:lstStyle/>
           <a:p>
-            <a:pPr algn="ctr" indent="0" marL="0">
+            <a:pPr marL="0" indent="0" algn="ctr">
               <a:buNone/>
             </a:pPr>
             <a:r>
@@ -6690,7 +6507,7 @@
           <a:bodyPr wrap="square" rtlCol="0" anchor="ctr"/>
           <a:lstStyle/>
           <a:p>
-            <a:pPr algn="ctr" indent="0" marL="0">
+            <a:pPr marL="0" indent="0" algn="ctr">
               <a:buNone/>
             </a:pPr>
             <a:r>
@@ -6729,7 +6546,7 @@
           <a:bodyPr wrap="square" rtlCol="0" anchor="ctr"/>
           <a:lstStyle/>
           <a:p>
-            <a:pPr algn="ctr" indent="0" marL="0">
+            <a:pPr marL="0" indent="0" algn="ctr">
               <a:buNone/>
             </a:pPr>
             <a:r>
@@ -6768,7 +6585,7 @@
           <a:bodyPr wrap="square" rtlCol="0" anchor="ctr"/>
           <a:lstStyle/>
           <a:p>
-            <a:pPr algn="l" indent="0" marL="0">
+            <a:pPr marL="0" indent="0" algn="l">
               <a:buNone/>
             </a:pPr>
             <a:r>
@@ -6807,7 +6624,7 @@
           <a:bodyPr wrap="square" rtlCol="0" anchor="ctr"/>
           <a:lstStyle/>
           <a:p>
-            <a:pPr algn="ctr" indent="0" marL="0">
+            <a:pPr marL="0" indent="0" algn="ctr">
               <a:buNone/>
             </a:pPr>
             <a:r>
@@ -6846,7 +6663,7 @@
           <a:bodyPr wrap="square" rtlCol="0" anchor="ctr"/>
           <a:lstStyle/>
           <a:p>
-            <a:pPr algn="ctr" indent="0" marL="0">
+            <a:pPr marL="0" indent="0" algn="ctr">
               <a:buNone/>
             </a:pPr>
             <a:r>
@@ -6885,7 +6702,7 @@
           <a:bodyPr wrap="square" rtlCol="0" anchor="ctr"/>
           <a:lstStyle/>
           <a:p>
-            <a:pPr algn="ctr" indent="0" marL="0">
+            <a:pPr marL="0" indent="0" algn="ctr">
               <a:buNone/>
             </a:pPr>
             <a:r>
@@ -6924,7 +6741,7 @@
           <a:bodyPr wrap="square" rtlCol="0" anchor="ctr"/>
           <a:lstStyle/>
           <a:p>
-            <a:pPr algn="l" indent="0" marL="0">
+            <a:pPr marL="0" indent="0" algn="l">
               <a:buNone/>
             </a:pPr>
             <a:r>
@@ -6963,7 +6780,7 @@
           <a:bodyPr wrap="square" rtlCol="0" anchor="ctr"/>
           <a:lstStyle/>
           <a:p>
-            <a:pPr algn="ctr" indent="0" marL="0">
+            <a:pPr marL="0" indent="0" algn="ctr">
               <a:buNone/>
             </a:pPr>
             <a:r>
@@ -7002,7 +6819,7 @@
           <a:bodyPr wrap="square" rtlCol="0" anchor="ctr"/>
           <a:lstStyle/>
           <a:p>
-            <a:pPr algn="ctr" indent="0" marL="0">
+            <a:pPr marL="0" indent="0" algn="ctr">
               <a:buNone/>
             </a:pPr>
             <a:r>
@@ -7041,7 +6858,7 @@
           <a:bodyPr wrap="square" rtlCol="0" anchor="ctr"/>
           <a:lstStyle/>
           <a:p>
-            <a:pPr algn="ctr" indent="0" marL="0">
+            <a:pPr marL="0" indent="0" algn="ctr">
               <a:buNone/>
             </a:pPr>
             <a:r>
@@ -7080,7 +6897,7 @@
           <a:bodyPr wrap="square" rtlCol="0" anchor="ctr"/>
           <a:lstStyle/>
           <a:p>
-            <a:pPr algn="l" indent="0" marL="0">
+            <a:pPr marL="0" indent="0" algn="l">
               <a:buNone/>
             </a:pPr>
             <a:r>
@@ -7119,7 +6936,7 @@
           <a:bodyPr wrap="square" rtlCol="0" anchor="ctr"/>
           <a:lstStyle/>
           <a:p>
-            <a:pPr algn="ctr" indent="0" marL="0">
+            <a:pPr marL="0" indent="0" algn="ctr">
               <a:buNone/>
             </a:pPr>
             <a:r>
@@ -7158,7 +6975,7 @@
           <a:bodyPr wrap="square" rtlCol="0" anchor="ctr"/>
           <a:lstStyle/>
           <a:p>
-            <a:pPr algn="ctr" indent="0" marL="0">
+            <a:pPr marL="0" indent="0" algn="ctr">
               <a:buNone/>
             </a:pPr>
             <a:r>
@@ -7197,7 +7014,7 @@
           <a:bodyPr wrap="square" rtlCol="0" anchor="ctr"/>
           <a:lstStyle/>
           <a:p>
-            <a:pPr algn="ctr" indent="0" marL="0">
+            <a:pPr marL="0" indent="0" algn="ctr">
               <a:buNone/>
             </a:pPr>
             <a:r>
@@ -7236,7 +7053,7 @@
           <a:bodyPr wrap="square" rtlCol="0" anchor="ctr"/>
           <a:lstStyle/>
           <a:p>
-            <a:pPr algn="l" indent="0" marL="0">
+            <a:pPr marL="0" indent="0" algn="l">
               <a:buNone/>
             </a:pPr>
             <a:r>
@@ -7275,7 +7092,7 @@
           <a:bodyPr wrap="square" rtlCol="0" anchor="ctr"/>
           <a:lstStyle/>
           <a:p>
-            <a:pPr algn="ctr" indent="0" marL="0">
+            <a:pPr marL="0" indent="0" algn="ctr">
               <a:buNone/>
             </a:pPr>
             <a:r>
@@ -7314,7 +7131,7 @@
           <a:bodyPr wrap="square" rtlCol="0" anchor="ctr"/>
           <a:lstStyle/>
           <a:p>
-            <a:pPr algn="ctr" indent="0" marL="0">
+            <a:pPr marL="0" indent="0" algn="ctr">
               <a:buNone/>
             </a:pPr>
             <a:r>
@@ -7353,7 +7170,7 @@
           <a:bodyPr wrap="square" rtlCol="0" anchor="ctr"/>
           <a:lstStyle/>
           <a:p>
-            <a:pPr algn="ctr" indent="0" marL="0">
+            <a:pPr marL="0" indent="0" algn="ctr">
               <a:buNone/>
             </a:pPr>
             <a:r>
@@ -7392,7 +7209,7 @@
           <a:bodyPr wrap="square" rtlCol="0" anchor="ctr"/>
           <a:lstStyle/>
           <a:p>
-            <a:pPr algn="l" indent="0" marL="0">
+            <a:pPr marL="0" indent="0" algn="l">
               <a:buNone/>
             </a:pPr>
             <a:r>
@@ -7431,7 +7248,7 @@
           <a:bodyPr wrap="square" rtlCol="0" anchor="ctr"/>
           <a:lstStyle/>
           <a:p>
-            <a:pPr algn="ctr" indent="0" marL="0">
+            <a:pPr marL="0" indent="0" algn="ctr">
               <a:buNone/>
             </a:pPr>
             <a:r>
@@ -7470,7 +7287,7 @@
           <a:bodyPr wrap="square" rtlCol="0" anchor="ctr"/>
           <a:lstStyle/>
           <a:p>
-            <a:pPr algn="ctr" indent="0" marL="0">
+            <a:pPr marL="0" indent="0" algn="ctr">
               <a:buNone/>
             </a:pPr>
             <a:r>
@@ -7509,7 +7326,7 @@
           <a:bodyPr wrap="square" rtlCol="0" anchor="ctr"/>
           <a:lstStyle/>
           <a:p>
-            <a:pPr algn="ctr" indent="0" marL="0">
+            <a:pPr marL="0" indent="0" algn="ctr">
               <a:buNone/>
             </a:pPr>
             <a:r>
@@ -7548,7 +7365,7 @@
           <a:bodyPr wrap="square" rtlCol="0" anchor="ctr"/>
           <a:lstStyle/>
           <a:p>
-            <a:pPr indent="0" marL="0">
+            <a:pPr marL="0" indent="0">
               <a:buNone/>
             </a:pPr>
             <a:r>
@@ -7582,6 +7399,7 @@
         <a:solidFill>
           <a:srgbClr val="1A1A1A"/>
         </a:solidFill>
+        <a:effectLst/>
       </p:bgPr>
     </p:bg>
     <p:spTree>
@@ -7619,7 +7437,7 @@
           <a:bodyPr wrap="square" rtlCol="0" anchor="ctr"/>
           <a:lstStyle/>
           <a:p>
-            <a:pPr indent="0" marL="0">
+            <a:pPr marL="0" indent="0">
               <a:buNone/>
             </a:pPr>
             <a:r>
@@ -7658,7 +7476,7 @@
           <a:bodyPr wrap="square" rtlCol="0" anchor="ctr"/>
           <a:lstStyle/>
           <a:p>
-            <a:pPr indent="0" marL="0">
+            <a:pPr marL="0" indent="0">
               <a:buNone/>
             </a:pPr>
             <a:r>
@@ -7719,7 +7537,7 @@
           <a:bodyPr wrap="square" rtlCol="0" anchor="ctr"/>
           <a:lstStyle/>
           <a:p>
-            <a:pPr algn="ctr" indent="0" marL="0">
+            <a:pPr marL="0" indent="0" algn="ctr">
               <a:buNone/>
             </a:pPr>
             <a:r>
@@ -7758,7 +7576,7 @@
           <a:bodyPr wrap="square" rtlCol="0" anchor="ctr"/>
           <a:lstStyle/>
           <a:p>
-            <a:pPr algn="ctr" indent="0" marL="0">
+            <a:pPr marL="0" indent="0" algn="ctr">
               <a:buNone/>
             </a:pPr>
             <a:r>
@@ -7797,7 +7615,7 @@
           <a:bodyPr wrap="square" rtlCol="0" anchor="ctr"/>
           <a:lstStyle/>
           <a:p>
-            <a:pPr indent="0" marL="0">
+            <a:pPr marL="0" indent="0">
               <a:buNone/>
             </a:pPr>
             <a:r>
@@ -7836,7 +7654,7 @@
           <a:bodyPr wrap="square" rtlCol="0" anchor="ctr"/>
           <a:lstStyle/>
           <a:p>
-            <a:pPr indent="0" marL="0">
+            <a:pPr marL="0" indent="0">
               <a:buNone/>
             </a:pPr>
             <a:r>
@@ -7875,7 +7693,7 @@
           <a:bodyPr wrap="square" rtlCol="0" anchor="ctr"/>
           <a:lstStyle/>
           <a:p>
-            <a:pPr indent="0" marL="0">
+            <a:pPr marL="0" indent="0">
               <a:buNone/>
             </a:pPr>
             <a:r>
@@ -7936,7 +7754,7 @@
           <a:bodyPr wrap="square" rtlCol="0" anchor="ctr"/>
           <a:lstStyle/>
           <a:p>
-            <a:pPr algn="ctr" indent="0" marL="0">
+            <a:pPr marL="0" indent="0" algn="ctr">
               <a:buNone/>
             </a:pPr>
             <a:r>
@@ -7975,7 +7793,7 @@
           <a:bodyPr wrap="square" rtlCol="0" anchor="ctr"/>
           <a:lstStyle/>
           <a:p>
-            <a:pPr algn="ctr" indent="0" marL="0">
+            <a:pPr marL="0" indent="0" algn="ctr">
               <a:buNone/>
             </a:pPr>
             <a:r>
@@ -8014,7 +7832,7 @@
           <a:bodyPr wrap="square" rtlCol="0" anchor="ctr"/>
           <a:lstStyle/>
           <a:p>
-            <a:pPr indent="0" marL="0">
+            <a:pPr marL="0" indent="0">
               <a:buNone/>
             </a:pPr>
             <a:r>
@@ -8053,7 +7871,7 @@
           <a:bodyPr wrap="square" rtlCol="0" anchor="ctr"/>
           <a:lstStyle/>
           <a:p>
-            <a:pPr indent="0" marL="0">
+            <a:pPr marL="0" indent="0">
               <a:buNone/>
             </a:pPr>
             <a:r>
@@ -8092,7 +7910,7 @@
           <a:bodyPr wrap="square" rtlCol="0" anchor="ctr"/>
           <a:lstStyle/>
           <a:p>
-            <a:pPr indent="0" marL="0">
+            <a:pPr marL="0" indent="0">
               <a:buNone/>
             </a:pPr>
             <a:r>
@@ -8153,7 +7971,7 @@
           <a:bodyPr wrap="square" rtlCol="0" anchor="ctr"/>
           <a:lstStyle/>
           <a:p>
-            <a:pPr algn="ctr" indent="0" marL="0">
+            <a:pPr marL="0" indent="0" algn="ctr">
               <a:buNone/>
             </a:pPr>
             <a:r>
@@ -8192,7 +8010,7 @@
           <a:bodyPr wrap="square" rtlCol="0" anchor="ctr"/>
           <a:lstStyle/>
           <a:p>
-            <a:pPr algn="ctr" indent="0" marL="0">
+            <a:pPr marL="0" indent="0" algn="ctr">
               <a:buNone/>
             </a:pPr>
             <a:r>
@@ -8231,7 +8049,7 @@
           <a:bodyPr wrap="square" rtlCol="0" anchor="ctr"/>
           <a:lstStyle/>
           <a:p>
-            <a:pPr indent="0" marL="0">
+            <a:pPr marL="0" indent="0">
               <a:buNone/>
             </a:pPr>
             <a:r>
@@ -8270,7 +8088,7 @@
           <a:bodyPr wrap="square" rtlCol="0" anchor="ctr"/>
           <a:lstStyle/>
           <a:p>
-            <a:pPr indent="0" marL="0">
+            <a:pPr marL="0" indent="0">
               <a:buNone/>
             </a:pPr>
             <a:r>
@@ -8309,7 +8127,7 @@
           <a:bodyPr wrap="square" rtlCol="0" anchor="ctr"/>
           <a:lstStyle/>
           <a:p>
-            <a:pPr indent="0" marL="0">
+            <a:pPr marL="0" indent="0">
               <a:buNone/>
             </a:pPr>
             <a:r>
@@ -8370,7 +8188,7 @@
           <a:bodyPr wrap="square" rtlCol="0" anchor="ctr"/>
           <a:lstStyle/>
           <a:p>
-            <a:pPr algn="ctr" indent="0" marL="0">
+            <a:pPr marL="0" indent="0" algn="ctr">
               <a:buNone/>
             </a:pPr>
             <a:r>
@@ -8409,7 +8227,7 @@
           <a:bodyPr wrap="square" rtlCol="0" anchor="ctr"/>
           <a:lstStyle/>
           <a:p>
-            <a:pPr algn="ctr" indent="0" marL="0">
+            <a:pPr marL="0" indent="0" algn="ctr">
               <a:buNone/>
             </a:pPr>
             <a:r>
@@ -8448,7 +8266,7 @@
           <a:bodyPr wrap="square" rtlCol="0" anchor="ctr"/>
           <a:lstStyle/>
           <a:p>
-            <a:pPr indent="0" marL="0">
+            <a:pPr marL="0" indent="0">
               <a:buNone/>
             </a:pPr>
             <a:r>
@@ -8487,7 +8305,7 @@
           <a:bodyPr wrap="square" rtlCol="0" anchor="ctr"/>
           <a:lstStyle/>
           <a:p>
-            <a:pPr indent="0" marL="0">
+            <a:pPr marL="0" indent="0">
               <a:buNone/>
             </a:pPr>
             <a:r>
@@ -8526,7 +8344,7 @@
           <a:bodyPr wrap="square" rtlCol="0" anchor="ctr"/>
           <a:lstStyle/>
           <a:p>
-            <a:pPr indent="0" marL="0">
+            <a:pPr marL="0" indent="0">
               <a:buNone/>
             </a:pPr>
             <a:r>
@@ -8572,7 +8390,7 @@
         </p:nvSpPr>
         <p:spPr>
           <a:xfrm>
-            <a:off x="1371600" y="5669280"/>
+            <a:off x="1485900" y="5669280"/>
             <a:ext cx="228600" cy="228600"/>
           </a:xfrm>
           <a:prstGeom prst="ellipse">
@@ -8605,7 +8423,7 @@
           <a:bodyPr wrap="square" rtlCol="0" anchor="ctr"/>
           <a:lstStyle/>
           <a:p>
-            <a:pPr algn="ctr" indent="0" marL="0">
+            <a:pPr marL="0" indent="0" algn="ctr">
               <a:buNone/>
             </a:pPr>
             <a:r>
@@ -8639,6 +8457,7 @@
         <a:solidFill>
           <a:srgbClr val="FFFFFF"/>
         </a:solidFill>
+        <a:effectLst/>
       </p:bgPr>
     </p:bg>
     <p:spTree>
@@ -8676,7 +8495,7 @@
           <a:bodyPr wrap="square" rtlCol="0" anchor="ctr"/>
           <a:lstStyle/>
           <a:p>
-            <a:pPr indent="0" marL="0">
+            <a:pPr marL="0" indent="0">
               <a:buNone/>
             </a:pPr>
             <a:r>
@@ -8715,7 +8534,7 @@
           <a:bodyPr wrap="square" rtlCol="0" anchor="ctr"/>
           <a:lstStyle/>
           <a:p>
-            <a:pPr indent="0" marL="0">
+            <a:pPr marL="0" indent="0">
               <a:buNone/>
             </a:pPr>
             <a:r>
@@ -8727,7 +8546,29 @@
                 <a:ea typeface="Arial" pitchFamily="34" charset="-122"/>
                 <a:cs typeface="Arial" pitchFamily="34" charset="-120"/>
               </a:rPr>
-              <a:t>Built by people who care about truth.</a:t>
+              <a:t>Built by </a:t>
+            </a:r>
+            <a:r>
+              <a:rPr lang="en-US" sz="4000" b="1" dirty="0" smtClean="0">
+                <a:solidFill>
+                  <a:srgbClr val="1A1A1A"/>
+                </a:solidFill>
+                <a:latin typeface="Arial" pitchFamily="34" charset="0"/>
+                <a:ea typeface="Arial" pitchFamily="34" charset="-122"/>
+                <a:cs typeface="Arial" pitchFamily="34" charset="-120"/>
+              </a:rPr>
+              <a:t>Someone who cares </a:t>
+            </a:r>
+            <a:r>
+              <a:rPr lang="en-US" sz="4000" b="1" dirty="0">
+                <a:solidFill>
+                  <a:srgbClr val="1A1A1A"/>
+                </a:solidFill>
+                <a:latin typeface="Arial" pitchFamily="34" charset="0"/>
+                <a:ea typeface="Arial" pitchFamily="34" charset="-122"/>
+                <a:cs typeface="Arial" pitchFamily="34" charset="-120"/>
+              </a:rPr>
+              <a:t>about truth.</a:t>
             </a:r>
             <a:endParaRPr lang="en-US" sz="4000" dirty="0"/>
           </a:p>
@@ -8741,15 +8582,19 @@
         </p:nvSpPr>
         <p:spPr>
           <a:xfrm>
-            <a:off x="1691640" y="2103120"/>
+            <a:off x="4478834" y="2431786"/>
             <a:ext cx="1371600" cy="1371600"/>
           </a:xfrm>
           <a:prstGeom prst="ellipse">
             <a:avLst/>
           </a:prstGeom>
-          <a:solidFill>
-            <a:srgbClr val="F5F5F7"/>
-          </a:solidFill>
+          <a:blipFill dpi="0" rotWithShape="1">
+            <a:blip r:embed="rId3"/>
+            <a:srcRect/>
+            <a:stretch>
+              <a:fillRect l="1000" t="-4000" r="-6000" b="-21000"/>
+            </a:stretch>
+          </a:blipFill>
           <a:ln/>
         </p:spPr>
       </p:sp>
@@ -8761,7 +8606,7 @@
         </p:nvSpPr>
         <p:spPr>
           <a:xfrm>
-            <a:off x="640080" y="3657600"/>
+            <a:off x="3486796" y="4132052"/>
             <a:ext cx="3474720" cy="457200"/>
           </a:xfrm>
           <a:prstGeom prst="rect">
@@ -8774,7 +8619,7 @@
           <a:bodyPr wrap="square" rtlCol="0" anchor="ctr"/>
           <a:lstStyle/>
           <a:p>
-            <a:pPr algn="ctr" indent="0" marL="0">
+            <a:pPr marL="0" indent="0" algn="ctr">
               <a:buNone/>
             </a:pPr>
             <a:r>
@@ -8800,7 +8645,7 @@
         </p:nvSpPr>
         <p:spPr>
           <a:xfrm>
-            <a:off x="640080" y="4114800"/>
+            <a:off x="3400532" y="4502988"/>
             <a:ext cx="3474720" cy="731520"/>
           </a:xfrm>
           <a:prstGeom prst="rect">
@@ -8813,11 +8658,11 @@
           <a:bodyPr wrap="square" rtlCol="0" anchor="ctr"/>
           <a:lstStyle/>
           <a:p>
-            <a:pPr algn="ctr" indent="0" marL="0">
-              <a:buNone/>
-            </a:pPr>
-            <a:r>
-              <a:rPr lang="en-US" sz="1400" dirty="0">
+            <a:pPr marL="0" indent="0" algn="ctr">
+              <a:buNone/>
+            </a:pPr>
+            <a:r>
+              <a:rPr lang="en-US" sz="1400" dirty="0" smtClean="0">
                 <a:solidFill>
                   <a:srgbClr val="888888"/>
                 </a:solidFill>
@@ -8825,242 +8670,7 @@
                 <a:ea typeface="Arial" pitchFamily="34" charset="-122"/>
                 <a:cs typeface="Arial" pitchFamily="34" charset="-120"/>
               </a:rPr>
-              <a:t>[Your name and background]</a:t>
-            </a:r>
-            <a:endParaRPr lang="en-US" sz="1400" dirty="0"/>
-          </a:p>
-        </p:txBody>
-      </p:sp>
-      <p:sp>
-        <p:nvSpPr>
-          <p:cNvPr id="7" name="Shape 5"/>
-          <p:cNvSpPr/>
-          <p:nvPr/>
-        </p:nvSpPr>
-        <p:spPr>
-          <a:xfrm>
-            <a:off x="5440680" y="2103120"/>
-            <a:ext cx="1371600" cy="1371600"/>
-          </a:xfrm>
-          <a:prstGeom prst="ellipse">
-            <a:avLst/>
-          </a:prstGeom>
-          <a:solidFill>
-            <a:srgbClr val="F5F5F7"/>
-          </a:solidFill>
-          <a:ln/>
-        </p:spPr>
-      </p:sp>
-      <p:sp>
-        <p:nvSpPr>
-          <p:cNvPr id="8" name="Text 6"/>
-          <p:cNvSpPr txBox="1"/>
-          <p:nvPr/>
-        </p:nvSpPr>
-        <p:spPr>
-          <a:xfrm>
-            <a:off x="4389120" y="3657600"/>
-            <a:ext cx="3474720" cy="457200"/>
-          </a:xfrm>
-          <a:prstGeom prst="rect">
-            <a:avLst/>
-          </a:prstGeom>
-          <a:noFill/>
-          <a:ln/>
-        </p:spPr>
-        <p:txBody>
-          <a:bodyPr wrap="square" rtlCol="0" anchor="ctr"/>
-          <a:lstStyle/>
-          <a:p>
-            <a:pPr algn="ctr" indent="0" marL="0">
-              <a:buNone/>
-            </a:pPr>
-            <a:r>
-              <a:rPr lang="en-US" sz="1800" b="1" dirty="0">
-                <a:solidFill>
-                  <a:srgbClr val="1A1A1A"/>
-                </a:solidFill>
-                <a:latin typeface="Arial" pitchFamily="34" charset="0"/>
-                <a:ea typeface="Arial" pitchFamily="34" charset="-122"/>
-                <a:cs typeface="Arial" pitchFamily="34" charset="-120"/>
-              </a:rPr>
-              <a:t>CTO</a:t>
-            </a:r>
-            <a:endParaRPr lang="en-US" sz="1800" dirty="0"/>
-          </a:p>
-        </p:txBody>
-      </p:sp>
-      <p:sp>
-        <p:nvSpPr>
-          <p:cNvPr id="9" name="Text 7"/>
-          <p:cNvSpPr txBox="1"/>
-          <p:nvPr/>
-        </p:nvSpPr>
-        <p:spPr>
-          <a:xfrm>
-            <a:off x="4389120" y="4114800"/>
-            <a:ext cx="3474720" cy="731520"/>
-          </a:xfrm>
-          <a:prstGeom prst="rect">
-            <a:avLst/>
-          </a:prstGeom>
-          <a:noFill/>
-          <a:ln/>
-        </p:spPr>
-        <p:txBody>
-          <a:bodyPr wrap="square" rtlCol="0" anchor="ctr"/>
-          <a:lstStyle/>
-          <a:p>
-            <a:pPr algn="ctr" indent="0" marL="0">
-              <a:buNone/>
-            </a:pPr>
-            <a:r>
-              <a:rPr lang="en-US" sz="1400" dirty="0">
-                <a:solidFill>
-                  <a:srgbClr val="888888"/>
-                </a:solidFill>
-                <a:latin typeface="Arial" pitchFamily="34" charset="0"/>
-                <a:ea typeface="Arial" pitchFamily="34" charset="-122"/>
-                <a:cs typeface="Arial" pitchFamily="34" charset="-120"/>
-              </a:rPr>
-              <a:t>[Technical co-founder]</a:t>
-            </a:r>
-            <a:endParaRPr lang="en-US" sz="1400" dirty="0"/>
-          </a:p>
-        </p:txBody>
-      </p:sp>
-      <p:sp>
-        <p:nvSpPr>
-          <p:cNvPr id="10" name="Shape 8"/>
-          <p:cNvSpPr/>
-          <p:nvPr/>
-        </p:nvSpPr>
-        <p:spPr>
-          <a:xfrm>
-            <a:off x="9189720" y="2103120"/>
-            <a:ext cx="1371600" cy="1371600"/>
-          </a:xfrm>
-          <a:prstGeom prst="ellipse">
-            <a:avLst/>
-          </a:prstGeom>
-          <a:solidFill>
-            <a:srgbClr val="F5F5F7"/>
-          </a:solidFill>
-          <a:ln/>
-        </p:spPr>
-      </p:sp>
-      <p:sp>
-        <p:nvSpPr>
-          <p:cNvPr id="11" name="Text 9"/>
-          <p:cNvSpPr txBox="1"/>
-          <p:nvPr/>
-        </p:nvSpPr>
-        <p:spPr>
-          <a:xfrm>
-            <a:off x="8138160" y="3657600"/>
-            <a:ext cx="3474720" cy="457200"/>
-          </a:xfrm>
-          <a:prstGeom prst="rect">
-            <a:avLst/>
-          </a:prstGeom>
-          <a:noFill/>
-          <a:ln/>
-        </p:spPr>
-        <p:txBody>
-          <a:bodyPr wrap="square" rtlCol="0" anchor="ctr"/>
-          <a:lstStyle/>
-          <a:p>
-            <a:pPr algn="ctr" indent="0" marL="0">
-              <a:buNone/>
-            </a:pPr>
-            <a:r>
-              <a:rPr lang="en-US" sz="1800" b="1" dirty="0">
-                <a:solidFill>
-                  <a:srgbClr val="1A1A1A"/>
-                </a:solidFill>
-                <a:latin typeface="Arial" pitchFamily="34" charset="0"/>
-                <a:ea typeface="Arial" pitchFamily="34" charset="-122"/>
-                <a:cs typeface="Arial" pitchFamily="34" charset="-120"/>
-              </a:rPr>
-              <a:t>Head of Product</a:t>
-            </a:r>
-            <a:endParaRPr lang="en-US" sz="1800" dirty="0"/>
-          </a:p>
-        </p:txBody>
-      </p:sp>
-      <p:sp>
-        <p:nvSpPr>
-          <p:cNvPr id="12" name="Text 10"/>
-          <p:cNvSpPr txBox="1"/>
-          <p:nvPr/>
-        </p:nvSpPr>
-        <p:spPr>
-          <a:xfrm>
-            <a:off x="8138160" y="4114800"/>
-            <a:ext cx="3474720" cy="731520"/>
-          </a:xfrm>
-          <a:prstGeom prst="rect">
-            <a:avLst/>
-          </a:prstGeom>
-          <a:noFill/>
-          <a:ln/>
-        </p:spPr>
-        <p:txBody>
-          <a:bodyPr wrap="square" rtlCol="0" anchor="ctr"/>
-          <a:lstStyle/>
-          <a:p>
-            <a:pPr algn="ctr" indent="0" marL="0">
-              <a:buNone/>
-            </a:pPr>
-            <a:r>
-              <a:rPr lang="en-US" sz="1400" dirty="0">
-                <a:solidFill>
-                  <a:srgbClr val="888888"/>
-                </a:solidFill>
-                <a:latin typeface="Arial" pitchFamily="34" charset="0"/>
-                <a:ea typeface="Arial" pitchFamily="34" charset="-122"/>
-                <a:cs typeface="Arial" pitchFamily="34" charset="-120"/>
-              </a:rPr>
-              <a:t>[Product leader]</a:t>
-            </a:r>
-            <a:endParaRPr lang="en-US" sz="1400" dirty="0"/>
-          </a:p>
-        </p:txBody>
-      </p:sp>
-      <p:sp>
-        <p:nvSpPr>
-          <p:cNvPr id="13" name="Text 11"/>
-          <p:cNvSpPr txBox="1"/>
-          <p:nvPr/>
-        </p:nvSpPr>
-        <p:spPr>
-          <a:xfrm>
-            <a:off x="640080" y="5486400"/>
-            <a:ext cx="10972800" cy="457200"/>
-          </a:xfrm>
-          <a:prstGeom prst="rect">
-            <a:avLst/>
-          </a:prstGeom>
-          <a:noFill/>
-          <a:ln/>
-        </p:spPr>
-        <p:txBody>
-          <a:bodyPr wrap="square" rtlCol="0" anchor="ctr"/>
-          <a:lstStyle/>
-          <a:p>
-            <a:pPr algn="ctr" indent="0" marL="0">
-              <a:buNone/>
-            </a:pPr>
-            <a:r>
-              <a:rPr lang="en-US" sz="1400" i="1" dirty="0">
-                <a:solidFill>
-                  <a:srgbClr val="888888"/>
-                </a:solidFill>
-                <a:latin typeface="Arial" pitchFamily="34" charset="0"/>
-                <a:ea typeface="Arial" pitchFamily="34" charset="-122"/>
-                <a:cs typeface="Arial" pitchFamily="34" charset="-120"/>
-              </a:rPr>
-              <a:t>Add your team bios, relevant experience, and why you're the right team to build this.</a:t>
+              <a:t>Opeyemi Ayeni</a:t>
             </a:r>
             <a:endParaRPr lang="en-US" sz="1400" dirty="0"/>
           </a:p>
@@ -9367,4 +8977,265 @@
     </a:ext>
   </a:extLst>
 </a:theme>
+</file>
+
+<file path=ppt/theme/theme2.xml><?xml version="1.0" encoding="utf-8"?>
+<a:theme xmlns:a="http://schemas.openxmlformats.org/drawingml/2006/main" name="Office Theme">
+  <a:themeElements>
+    <a:clrScheme name="Office">
+      <a:dk1>
+        <a:sysClr val="windowText" lastClr="000000"/>
+      </a:dk1>
+      <a:lt1>
+        <a:sysClr val="window" lastClr="FFFFFF"/>
+      </a:lt1>
+      <a:dk2>
+        <a:srgbClr val="44546A"/>
+      </a:dk2>
+      <a:lt2>
+        <a:srgbClr val="E7E6E6"/>
+      </a:lt2>
+      <a:accent1>
+        <a:srgbClr val="5B9BD5"/>
+      </a:accent1>
+      <a:accent2>
+        <a:srgbClr val="ED7D31"/>
+      </a:accent2>
+      <a:accent3>
+        <a:srgbClr val="A5A5A5"/>
+      </a:accent3>
+      <a:accent4>
+        <a:srgbClr val="FFC000"/>
+      </a:accent4>
+      <a:accent5>
+        <a:srgbClr val="4472C4"/>
+      </a:accent5>
+      <a:accent6>
+        <a:srgbClr val="70AD47"/>
+      </a:accent6>
+      <a:hlink>
+        <a:srgbClr val="0563C1"/>
+      </a:hlink>
+      <a:folHlink>
+        <a:srgbClr val="954F72"/>
+      </a:folHlink>
+    </a:clrScheme>
+    <a:fontScheme name="Office">
+      <a:majorFont>
+        <a:latin typeface="Calibri Light" panose="020F0302020204030204"/>
+        <a:ea typeface=""/>
+        <a:cs typeface=""/>
+        <a:font script="Jpan" typeface="游ゴシック Light"/>
+        <a:font script="Hang" typeface="맑은 고딕"/>
+        <a:font script="Hans" typeface="等线 Light"/>
+        <a:font script="Hant" typeface="新細明體"/>
+        <a:font script="Arab" typeface="Times New Roman"/>
+        <a:font script="Hebr" typeface="Times New Roman"/>
+        <a:font script="Thai" typeface="Angsana New"/>
+        <a:font script="Ethi" typeface="Nyala"/>
+        <a:font script="Beng" typeface="Vrinda"/>
+        <a:font script="Gujr" typeface="Shruti"/>
+        <a:font script="Khmr" typeface="MoolBoran"/>
+        <a:font script="Knda" typeface="Tunga"/>
+        <a:font script="Guru" typeface="Raavi"/>
+        <a:font script="Cans" typeface="Euphemia"/>
+        <a:font script="Cher" typeface="Plantagenet Cherokee"/>
+        <a:font script="Yiii" typeface="Microsoft Yi Baiti"/>
+        <a:font script="Tibt" typeface="Microsoft Himalaya"/>
+        <a:font script="Thaa" typeface="MV Boli"/>
+        <a:font script="Deva" typeface="Mangal"/>
+        <a:font script="Telu" typeface="Gautami"/>
+        <a:font script="Taml" typeface="Latha"/>
+        <a:font script="Syrc" typeface="Estrangelo Edessa"/>
+        <a:font script="Orya" typeface="Kalinga"/>
+        <a:font script="Mlym" typeface="Kartika"/>
+        <a:font script="Laoo" typeface="DokChampa"/>
+        <a:font script="Sinh" typeface="Iskoola Pota"/>
+        <a:font script="Mong" typeface="Mongolian Baiti"/>
+        <a:font script="Viet" typeface="Times New Roman"/>
+        <a:font script="Uigh" typeface="Microsoft Uighur"/>
+        <a:font script="Geor" typeface="Sylfaen"/>
+      </a:majorFont>
+      <a:minorFont>
+        <a:latin typeface="Calibri" panose="020F0502020204030204"/>
+        <a:ea typeface=""/>
+        <a:cs typeface=""/>
+        <a:font script="Jpan" typeface="游ゴシック"/>
+        <a:font script="Hang" typeface="맑은 고딕"/>
+        <a:font script="Hans" typeface="等线"/>
+        <a:font script="Hant" typeface="新細明體"/>
+        <a:font script="Arab" typeface="Arial"/>
+        <a:font script="Hebr" typeface="Arial"/>
+        <a:font script="Thai" typeface="Cordia New"/>
+        <a:font script="Ethi" typeface="Nyala"/>
+        <a:font script="Beng" typeface="Vrinda"/>
+        <a:font script="Gujr" typeface="Shruti"/>
+        <a:font script="Khmr" typeface="DaunPenh"/>
+        <a:font script="Knda" typeface="Tunga"/>
+        <a:font script="Guru" typeface="Raavi"/>
+        <a:font script="Cans" typeface="Euphemia"/>
+        <a:font script="Cher" typeface="Plantagenet Cherokee"/>
+        <a:font script="Yiii" typeface="Microsoft Yi Baiti"/>
+        <a:font script="Tibt" typeface="Microsoft Himalaya"/>
+        <a:font script="Thaa" typeface="MV Boli"/>
+        <a:font script="Deva" typeface="Mangal"/>
+        <a:font script="Telu" typeface="Gautami"/>
+        <a:font script="Taml" typeface="Latha"/>
+        <a:font script="Syrc" typeface="Estrangelo Edessa"/>
+        <a:font script="Orya" typeface="Kalinga"/>
+        <a:font script="Mlym" typeface="Kartika"/>
+        <a:font script="Laoo" typeface="DokChampa"/>
+        <a:font script="Sinh" typeface="Iskoola Pota"/>
+        <a:font script="Mong" typeface="Mongolian Baiti"/>
+        <a:font script="Viet" typeface="Arial"/>
+        <a:font script="Uigh" typeface="Microsoft Uighur"/>
+        <a:font script="Geor" typeface="Sylfaen"/>
+      </a:minorFont>
+    </a:fontScheme>
+    <a:fmtScheme name="Office">
+      <a:fillStyleLst>
+        <a:solidFill>
+          <a:schemeClr val="phClr"/>
+        </a:solidFill>
+        <a:gradFill rotWithShape="1">
+          <a:gsLst>
+            <a:gs pos="0">
+              <a:schemeClr val="phClr">
+                <a:lumMod val="110000"/>
+                <a:satMod val="105000"/>
+                <a:tint val="67000"/>
+              </a:schemeClr>
+            </a:gs>
+            <a:gs pos="50000">
+              <a:schemeClr val="phClr">
+                <a:lumMod val="105000"/>
+                <a:satMod val="103000"/>
+                <a:tint val="73000"/>
+              </a:schemeClr>
+            </a:gs>
+            <a:gs pos="100000">
+              <a:schemeClr val="phClr">
+                <a:lumMod val="105000"/>
+                <a:satMod val="109000"/>
+                <a:tint val="81000"/>
+              </a:schemeClr>
+            </a:gs>
+          </a:gsLst>
+          <a:lin ang="5400000" scaled="0"/>
+        </a:gradFill>
+        <a:gradFill rotWithShape="1">
+          <a:gsLst>
+            <a:gs pos="0">
+              <a:schemeClr val="phClr">
+                <a:satMod val="103000"/>
+                <a:lumMod val="102000"/>
+                <a:tint val="94000"/>
+              </a:schemeClr>
+            </a:gs>
+            <a:gs pos="50000">
+              <a:schemeClr val="phClr">
+                <a:satMod val="110000"/>
+                <a:lumMod val="100000"/>
+                <a:shade val="100000"/>
+              </a:schemeClr>
+            </a:gs>
+            <a:gs pos="100000">
+              <a:schemeClr val="phClr">
+                <a:lumMod val="99000"/>
+                <a:satMod val="120000"/>
+                <a:shade val="78000"/>
+              </a:schemeClr>
+            </a:gs>
+          </a:gsLst>
+          <a:lin ang="5400000" scaled="0"/>
+        </a:gradFill>
+      </a:fillStyleLst>
+      <a:lnStyleLst>
+        <a:ln w="6350" cap="flat" cmpd="sng" algn="ctr">
+          <a:solidFill>
+            <a:schemeClr val="phClr"/>
+          </a:solidFill>
+          <a:prstDash val="solid"/>
+          <a:miter lim="800000"/>
+        </a:ln>
+        <a:ln w="12700" cap="flat" cmpd="sng" algn="ctr">
+          <a:solidFill>
+            <a:schemeClr val="phClr"/>
+          </a:solidFill>
+          <a:prstDash val="solid"/>
+          <a:miter lim="800000"/>
+        </a:ln>
+        <a:ln w="19050" cap="flat" cmpd="sng" algn="ctr">
+          <a:solidFill>
+            <a:schemeClr val="phClr"/>
+          </a:solidFill>
+          <a:prstDash val="solid"/>
+          <a:miter lim="800000"/>
+        </a:ln>
+      </a:lnStyleLst>
+      <a:effectStyleLst>
+        <a:effectStyle>
+          <a:effectLst/>
+        </a:effectStyle>
+        <a:effectStyle>
+          <a:effectLst/>
+        </a:effectStyle>
+        <a:effectStyle>
+          <a:effectLst>
+            <a:outerShdw blurRad="57150" dist="19050" dir="5400000" algn="ctr" rotWithShape="0">
+              <a:srgbClr val="000000">
+                <a:alpha val="63000"/>
+              </a:srgbClr>
+            </a:outerShdw>
+          </a:effectLst>
+        </a:effectStyle>
+      </a:effectStyleLst>
+      <a:bgFillStyleLst>
+        <a:solidFill>
+          <a:schemeClr val="phClr"/>
+        </a:solidFill>
+        <a:solidFill>
+          <a:schemeClr val="phClr">
+            <a:tint val="95000"/>
+            <a:satMod val="170000"/>
+          </a:schemeClr>
+        </a:solidFill>
+        <a:gradFill rotWithShape="1">
+          <a:gsLst>
+            <a:gs pos="0">
+              <a:schemeClr val="phClr">
+                <a:tint val="93000"/>
+                <a:satMod val="150000"/>
+                <a:shade val="98000"/>
+                <a:lumMod val="102000"/>
+              </a:schemeClr>
+            </a:gs>
+            <a:gs pos="50000">
+              <a:schemeClr val="phClr">
+                <a:tint val="98000"/>
+                <a:satMod val="130000"/>
+                <a:shade val="90000"/>
+                <a:lumMod val="103000"/>
+              </a:schemeClr>
+            </a:gs>
+            <a:gs pos="100000">
+              <a:schemeClr val="phClr">
+                <a:shade val="63000"/>
+                <a:satMod val="120000"/>
+              </a:schemeClr>
+            </a:gs>
+          </a:gsLst>
+          <a:lin ang="5400000" scaled="0"/>
+        </a:gradFill>
+      </a:bgFillStyleLst>
+    </a:fmtScheme>
+  </a:themeElements>
+  <a:objectDefaults/>
+  <a:extraClrSchemeLst/>
+  <a:extLst>
+    <a:ext uri="{05A4C25C-085E-4340-85A3-A5531E510DB2}">
+      <thm15:themeFamily xmlns:thm15="http://schemas.microsoft.com/office/thememl/2012/main" name="Office Theme" id="{62F939B6-93AF-4DB8-9C6B-D6C7DFDC589F}" vid="{4A3C46E8-61CC-4603-A589-7422A47A8E4A}"/>
+    </a:ext>
+  </a:extLst>
+</a:theme>
 </file>
</xml_diff>